<commit_message>
Day3 g4_skin_access: polish deck — fill sparse slides, big-stat + ref grid, speaker notes
</commit_message>
<xml_diff>
--- a/solutions/g4_skin_access/slides/g4_skin_access.pptx
+++ b/solutions/g4_skin_access/slides/g4_skin_access.pptx
@@ -7,22 +7,22 @@
   <p:sldIdLst>
     <p:sldId id="256" r:id="rId7"/>
     <p:sldId id="257" r:id="rId8"/>
-    <p:sldId id="258" r:id="rId9"/>
-    <p:sldId id="259" r:id="rId10"/>
-    <p:sldId id="260" r:id="rId11"/>
-    <p:sldId id="261" r:id="rId12"/>
-    <p:sldId id="262" r:id="rId13"/>
-    <p:sldId id="263" r:id="rId14"/>
-    <p:sldId id="264" r:id="rId15"/>
-    <p:sldId id="265" r:id="rId16"/>
-    <p:sldId id="266" r:id="rId17"/>
-    <p:sldId id="267" r:id="rId18"/>
-    <p:sldId id="268" r:id="rId19"/>
-    <p:sldId id="269" r:id="rId20"/>
-    <p:sldId id="270" r:id="rId21"/>
-    <p:sldId id="271" r:id="rId22"/>
-    <p:sldId id="272" r:id="rId23"/>
-    <p:sldId id="273" r:id="rId24"/>
+    <p:sldId id="258" r:id="rId10"/>
+    <p:sldId id="259" r:id="rId11"/>
+    <p:sldId id="260" r:id="rId12"/>
+    <p:sldId id="261" r:id="rId13"/>
+    <p:sldId id="262" r:id="rId14"/>
+    <p:sldId id="263" r:id="rId15"/>
+    <p:sldId id="264" r:id="rId16"/>
+    <p:sldId id="265" r:id="rId17"/>
+    <p:sldId id="266" r:id="rId18"/>
+    <p:sldId id="267" r:id="rId19"/>
+    <p:sldId id="268" r:id="rId20"/>
+    <p:sldId id="269" r:id="rId21"/>
+    <p:sldId id="270" r:id="rId22"/>
+    <p:sldId id="271" r:id="rId23"/>
+    <p:sldId id="272" r:id="rId24"/>
+    <p:sldId id="273" r:id="rId25"/>
   </p:sldIdLst>
   <p:sldSz cx="12191695" cy="6858000" type="screen4x3"/>
   <p:notesSz cx="6858000" cy="9144000"/>
@@ -122,6 +122,1652 @@
     </a:lvl9pPr>
   </p:defaultTextStyle>
 </p:presentation>
+</file>
+
+<file path=ppt/notesMasters/notesMaster1.xml><?xml version="1.0" encoding="utf-8"?>
+<p:notesMaster xmlns:a="http://schemas.openxmlformats.org/drawingml/2006/main" xmlns:p="http://schemas.openxmlformats.org/presentationml/2006/main" xmlns:r="http://schemas.openxmlformats.org/officeDocument/2006/relationships">
+  <p:cSld>
+    <p:bg>
+      <p:bgRef idx="1001">
+        <a:schemeClr val="bg1"/>
+      </p:bgRef>
+    </p:bg>
+    <p:spTree>
+      <p:nvGrpSpPr>
+        <p:cNvPr id="1" name=""/>
+        <p:cNvGrpSpPr/>
+        <p:nvPr/>
+      </p:nvGrpSpPr>
+      <p:grpSpPr>
+        <a:xfrm>
+          <a:off x="0" y="0"/>
+          <a:ext cx="0" cy="0"/>
+          <a:chOff x="0" y="0"/>
+          <a:chExt cx="0" cy="0"/>
+        </a:xfrm>
+      </p:grpSpPr>
+      <p:sp>
+        <p:nvSpPr>
+          <p:cNvPr id="2" name="Header Placeholder 1"/>
+          <p:cNvSpPr>
+            <a:spLocks noGrp="1"/>
+          </p:cNvSpPr>
+          <p:nvPr>
+            <p:ph type="hdr" sz="quarter"/>
+          </p:nvPr>
+        </p:nvSpPr>
+        <p:spPr>
+          <a:xfrm>
+            <a:off x="0" y="0"/>
+            <a:ext cx="2971800" cy="457200"/>
+          </a:xfrm>
+          <a:prstGeom prst="rect">
+            <a:avLst/>
+          </a:prstGeom>
+        </p:spPr>
+        <p:txBody>
+          <a:bodyPr vert="horz" lIns="91440" tIns="45720" rIns="91440" bIns="45720" rtlCol="0"/>
+          <a:lstStyle>
+            <a:lvl1pPr algn="l">
+              <a:defRPr sz="1200"/>
+            </a:lvl1pPr>
+          </a:lstStyle>
+          <a:p>
+            <a:endParaRPr lang="en-US"/>
+          </a:p>
+        </p:txBody>
+      </p:sp>
+      <p:sp>
+        <p:nvSpPr>
+          <p:cNvPr id="3" name="Date Placeholder 2"/>
+          <p:cNvSpPr>
+            <a:spLocks noGrp="1"/>
+          </p:cNvSpPr>
+          <p:nvPr>
+            <p:ph type="dt" idx="1"/>
+          </p:nvPr>
+        </p:nvSpPr>
+        <p:spPr>
+          <a:xfrm>
+            <a:off x="3884613" y="0"/>
+            <a:ext cx="2971800" cy="457200"/>
+          </a:xfrm>
+          <a:prstGeom prst="rect">
+            <a:avLst/>
+          </a:prstGeom>
+        </p:spPr>
+        <p:txBody>
+          <a:bodyPr vert="horz" lIns="91440" tIns="45720" rIns="91440" bIns="45720" rtlCol="0"/>
+          <a:lstStyle>
+            <a:lvl1pPr algn="r">
+              <a:defRPr sz="1200"/>
+            </a:lvl1pPr>
+          </a:lstStyle>
+          <a:p>
+            <a:fld id="{0F89C1C7-3DCD-1040-A9CF-14679D8B5DDD}" type="datetimeFigureOut">
+              <a:rPr lang="en-US" smtClean="0"/>
+              <a:t>10/17/16</a:t>
+            </a:fld>
+            <a:endParaRPr lang="en-US"/>
+          </a:p>
+        </p:txBody>
+      </p:sp>
+      <p:sp>
+        <p:nvSpPr>
+          <p:cNvPr id="4" name="Slide Image Placeholder 3"/>
+          <p:cNvSpPr>
+            <a:spLocks noGrp="1" noRot="1" noChangeAspect="1"/>
+          </p:cNvSpPr>
+          <p:nvPr>
+            <p:ph type="sldImg" idx="2"/>
+          </p:nvPr>
+        </p:nvSpPr>
+        <p:spPr>
+          <a:xfrm>
+            <a:off x="1143000" y="685800"/>
+            <a:ext cx="4572000" cy="3429000"/>
+          </a:xfrm>
+          <a:prstGeom prst="rect">
+            <a:avLst/>
+          </a:prstGeom>
+          <a:noFill/>
+          <a:ln w="12700">
+            <a:solidFill>
+              <a:prstClr val="black"/>
+            </a:solidFill>
+          </a:ln>
+        </p:spPr>
+        <p:txBody>
+          <a:bodyPr vert="horz" lIns="91440" tIns="45720" rIns="91440" bIns="45720" rtlCol="0" anchor="ctr"/>
+          <a:lstStyle/>
+          <a:p>
+            <a:endParaRPr lang="en-US"/>
+          </a:p>
+        </p:txBody>
+      </p:sp>
+      <p:sp>
+        <p:nvSpPr>
+          <p:cNvPr id="5" name="Notes Placeholder 4"/>
+          <p:cNvSpPr>
+            <a:spLocks noGrp="1"/>
+          </p:cNvSpPr>
+          <p:nvPr>
+            <p:ph type="body" sz="quarter" idx="3"/>
+          </p:nvPr>
+        </p:nvSpPr>
+        <p:spPr>
+          <a:xfrm>
+            <a:off x="685800" y="4343400"/>
+            <a:ext cx="5486400" cy="4114800"/>
+          </a:xfrm>
+          <a:prstGeom prst="rect">
+            <a:avLst/>
+          </a:prstGeom>
+        </p:spPr>
+        <p:txBody>
+          <a:bodyPr vert="horz" lIns="91440" tIns="45720" rIns="91440" bIns="45720" rtlCol="0"/>
+          <a:lstStyle/>
+          <a:p>
+            <a:pPr lvl="0"/>
+            <a:r>
+              <a:rPr lang="en-US" smtClean="0"/>
+              <a:t>Click to edit Master text styles</a:t>
+            </a:r>
+          </a:p>
+          <a:p>
+            <a:pPr lvl="1"/>
+            <a:r>
+              <a:rPr lang="en-US" smtClean="0"/>
+              <a:t>Second level</a:t>
+            </a:r>
+          </a:p>
+          <a:p>
+            <a:pPr lvl="2"/>
+            <a:r>
+              <a:rPr lang="en-US" smtClean="0"/>
+              <a:t>Third level</a:t>
+            </a:r>
+          </a:p>
+          <a:p>
+            <a:pPr lvl="3"/>
+            <a:r>
+              <a:rPr lang="en-US" smtClean="0"/>
+              <a:t>Fourth level</a:t>
+            </a:r>
+          </a:p>
+          <a:p>
+            <a:pPr lvl="4"/>
+            <a:r>
+              <a:rPr lang="en-US" smtClean="0"/>
+              <a:t>Fifth level</a:t>
+            </a:r>
+            <a:endParaRPr lang="en-US"/>
+          </a:p>
+        </p:txBody>
+      </p:sp>
+      <p:sp>
+        <p:nvSpPr>
+          <p:cNvPr id="6" name="Footer Placeholder 5"/>
+          <p:cNvSpPr>
+            <a:spLocks noGrp="1"/>
+          </p:cNvSpPr>
+          <p:nvPr>
+            <p:ph type="ftr" sz="quarter" idx="4"/>
+          </p:nvPr>
+        </p:nvSpPr>
+        <p:spPr>
+          <a:xfrm>
+            <a:off x="0" y="8685213"/>
+            <a:ext cx="2971800" cy="457200"/>
+          </a:xfrm>
+          <a:prstGeom prst="rect">
+            <a:avLst/>
+          </a:prstGeom>
+        </p:spPr>
+        <p:txBody>
+          <a:bodyPr vert="horz" lIns="91440" tIns="45720" rIns="91440" bIns="45720" rtlCol="0" anchor="b"/>
+          <a:lstStyle>
+            <a:lvl1pPr algn="l">
+              <a:defRPr sz="1200"/>
+            </a:lvl1pPr>
+          </a:lstStyle>
+          <a:p>
+            <a:endParaRPr lang="en-US"/>
+          </a:p>
+        </p:txBody>
+      </p:sp>
+      <p:sp>
+        <p:nvSpPr>
+          <p:cNvPr id="7" name="Slide Number Placeholder 6"/>
+          <p:cNvSpPr>
+            <a:spLocks noGrp="1"/>
+          </p:cNvSpPr>
+          <p:nvPr>
+            <p:ph type="sldNum" sz="quarter" idx="5"/>
+          </p:nvPr>
+        </p:nvSpPr>
+        <p:spPr>
+          <a:xfrm>
+            <a:off x="3884613" y="8685213"/>
+            <a:ext cx="2971800" cy="457200"/>
+          </a:xfrm>
+          <a:prstGeom prst="rect">
+            <a:avLst/>
+          </a:prstGeom>
+        </p:spPr>
+        <p:txBody>
+          <a:bodyPr vert="horz" lIns="91440" tIns="45720" rIns="91440" bIns="45720" rtlCol="0" anchor="b"/>
+          <a:lstStyle>
+            <a:lvl1pPr algn="r">
+              <a:defRPr sz="1200"/>
+            </a:lvl1pPr>
+          </a:lstStyle>
+          <a:p>
+            <a:fld id="{BB5E49A5-4136-284D-997B-48E1D791AD67}" type="slidenum">
+              <a:rPr lang="en-US" smtClean="0"/>
+              <a:t>‹#›</a:t>
+            </a:fld>
+            <a:endParaRPr lang="en-US"/>
+          </a:p>
+        </p:txBody>
+      </p:sp>
+    </p:spTree>
+    <p:extLst>
+      <p:ext uri="{BB962C8B-B14F-4D97-AF65-F5344CB8AC3E}">
+        <p14:creationId xmlns:p14="http://schemas.microsoft.com/office/powerpoint/2010/main" val="2623252185"/>
+      </p:ext>
+    </p:extLst>
+  </p:cSld>
+  <p:clrMap bg1="lt1" tx1="dk1" bg2="lt2" tx2="dk2" accent1="accent1" accent2="accent2" accent3="accent3" accent4="accent4" accent5="accent5" accent6="accent6" hlink="hlink" folHlink="folHlink"/>
+  <p:notesStyle>
+    <a:lvl1pPr marL="0" algn="l" defTabSz="457200" rtl="0" eaLnBrk="1" latinLnBrk="0" hangingPunct="1">
+      <a:defRPr sz="1200" kern="1200">
+        <a:solidFill>
+          <a:schemeClr val="tx1"/>
+        </a:solidFill>
+        <a:latin typeface="+mn-lt"/>
+        <a:ea typeface="+mn-ea"/>
+        <a:cs typeface="+mn-cs"/>
+      </a:defRPr>
+    </a:lvl1pPr>
+    <a:lvl2pPr marL="457200" algn="l" defTabSz="457200" rtl="0" eaLnBrk="1" latinLnBrk="0" hangingPunct="1">
+      <a:defRPr sz="1200" kern="1200">
+        <a:solidFill>
+          <a:schemeClr val="tx1"/>
+        </a:solidFill>
+        <a:latin typeface="+mn-lt"/>
+        <a:ea typeface="+mn-ea"/>
+        <a:cs typeface="+mn-cs"/>
+      </a:defRPr>
+    </a:lvl2pPr>
+    <a:lvl3pPr marL="914400" algn="l" defTabSz="457200" rtl="0" eaLnBrk="1" latinLnBrk="0" hangingPunct="1">
+      <a:defRPr sz="1200" kern="1200">
+        <a:solidFill>
+          <a:schemeClr val="tx1"/>
+        </a:solidFill>
+        <a:latin typeface="+mn-lt"/>
+        <a:ea typeface="+mn-ea"/>
+        <a:cs typeface="+mn-cs"/>
+      </a:defRPr>
+    </a:lvl3pPr>
+    <a:lvl4pPr marL="1371600" algn="l" defTabSz="457200" rtl="0" eaLnBrk="1" latinLnBrk="0" hangingPunct="1">
+      <a:defRPr sz="1200" kern="1200">
+        <a:solidFill>
+          <a:schemeClr val="tx1"/>
+        </a:solidFill>
+        <a:latin typeface="+mn-lt"/>
+        <a:ea typeface="+mn-ea"/>
+        <a:cs typeface="+mn-cs"/>
+      </a:defRPr>
+    </a:lvl4pPr>
+    <a:lvl5pPr marL="1828800" algn="l" defTabSz="457200" rtl="0" eaLnBrk="1" latinLnBrk="0" hangingPunct="1">
+      <a:defRPr sz="1200" kern="1200">
+        <a:solidFill>
+          <a:schemeClr val="tx1"/>
+        </a:solidFill>
+        <a:latin typeface="+mn-lt"/>
+        <a:ea typeface="+mn-ea"/>
+        <a:cs typeface="+mn-cs"/>
+      </a:defRPr>
+    </a:lvl5pPr>
+    <a:lvl6pPr marL="2286000" algn="l" defTabSz="457200" rtl="0" eaLnBrk="1" latinLnBrk="0" hangingPunct="1">
+      <a:defRPr sz="1200" kern="1200">
+        <a:solidFill>
+          <a:schemeClr val="tx1"/>
+        </a:solidFill>
+        <a:latin typeface="+mn-lt"/>
+        <a:ea typeface="+mn-ea"/>
+        <a:cs typeface="+mn-cs"/>
+      </a:defRPr>
+    </a:lvl6pPr>
+    <a:lvl7pPr marL="2743200" algn="l" defTabSz="457200" rtl="0" eaLnBrk="1" latinLnBrk="0" hangingPunct="1">
+      <a:defRPr sz="1200" kern="1200">
+        <a:solidFill>
+          <a:schemeClr val="tx1"/>
+        </a:solidFill>
+        <a:latin typeface="+mn-lt"/>
+        <a:ea typeface="+mn-ea"/>
+        <a:cs typeface="+mn-cs"/>
+      </a:defRPr>
+    </a:lvl7pPr>
+    <a:lvl8pPr marL="3200400" algn="l" defTabSz="457200" rtl="0" eaLnBrk="1" latinLnBrk="0" hangingPunct="1">
+      <a:defRPr sz="1200" kern="1200">
+        <a:solidFill>
+          <a:schemeClr val="tx1"/>
+        </a:solidFill>
+        <a:latin typeface="+mn-lt"/>
+        <a:ea typeface="+mn-ea"/>
+        <a:cs typeface="+mn-cs"/>
+      </a:defRPr>
+    </a:lvl8pPr>
+    <a:lvl9pPr marL="3657600" algn="l" defTabSz="457200" rtl="0" eaLnBrk="1" latinLnBrk="0" hangingPunct="1">
+      <a:defRPr sz="1200" kern="1200">
+        <a:solidFill>
+          <a:schemeClr val="tx1"/>
+        </a:solidFill>
+        <a:latin typeface="+mn-lt"/>
+        <a:ea typeface="+mn-ea"/>
+        <a:cs typeface="+mn-cs"/>
+      </a:defRPr>
+    </a:lvl9pPr>
+  </p:notesStyle>
+</p:notesMaster>
+</file>
+
+<file path=ppt/notesSlides/notesSlide1.xml><?xml version="1.0" encoding="utf-8"?>
+<p:notes xmlns:a="http://schemas.openxmlformats.org/drawingml/2006/main" xmlns:p="http://schemas.openxmlformats.org/presentationml/2006/main" xmlns:r="http://schemas.openxmlformats.org/officeDocument/2006/relationships">
+  <p:cSld>
+    <p:spTree>
+      <p:nvGrpSpPr>
+        <p:cNvPr id="1" name=""/>
+        <p:cNvGrpSpPr/>
+        <p:nvPr/>
+      </p:nvGrpSpPr>
+      <p:grpSpPr>
+        <a:xfrm>
+          <a:off x="0" y="0"/>
+          <a:ext cx="0" cy="0"/>
+          <a:chOff x="0" y="0"/>
+          <a:chExt cx="0" cy="0"/>
+        </a:xfrm>
+      </p:grpSpPr>
+      <p:sp>
+        <p:nvSpPr>
+          <p:cNvPr id="2" name="Slide Image Placeholder 1"/>
+          <p:cNvSpPr>
+            <a:spLocks noGrp="1"/>
+          </p:cNvSpPr>
+          <p:nvPr>
+            <p:ph type="sldImg" idx="2"/>
+          </p:nvPr>
+        </p:nvSpPr>
+        <p:spPr/>
+      </p:sp>
+      <p:sp>
+        <p:nvSpPr>
+          <p:cNvPr id="3" name="Notes Placeholder 2"/>
+          <p:cNvSpPr>
+            <a:spLocks noGrp="1"/>
+          </p:cNvSpPr>
+          <p:nvPr>
+            <p:ph type="body" idx="3" sz="quarter"/>
+          </p:nvPr>
+        </p:nvSpPr>
+        <p:spPr/>
+        <p:txBody>
+          <a:bodyPr/>
+          <a:lstStyle/>
+          <a:p>
+            <a:r>
+              <a:rPr b="1" sz="1300">
+                <a:latin typeface="Geist Mono"/>
+              </a:rPr>
+              <a:t>Background</a:t>
+            </a:r>
+          </a:p>
+          <a:p>
+            <a:r>
+              <a:rPr b="0" sz="1100">
+                <a:latin typeface="Geist"/>
+              </a:rPr>
+              <a:t>This section sets up the tension before any of our own results: skin-cancer AI is sold as a way to widen access, yet it learns from images that mostly show light skin. Prime students to ask 'good for whom?' rather than just 'is it accurate?'.</a:t>
+            </a:r>
+          </a:p>
+        </p:txBody>
+      </p:sp>
+      <p:sp>
+        <p:nvSpPr>
+          <p:cNvPr id="4" name="Slide Number Placeholder 3"/>
+          <p:cNvSpPr>
+            <a:spLocks noGrp="1"/>
+          </p:cNvSpPr>
+          <p:nvPr>
+            <p:ph type="sldNum" idx="5" sz="quarter"/>
+          </p:nvPr>
+        </p:nvSpPr>
+        <p:spPr/>
+      </p:sp>
+    </p:spTree>
+  </p:cSld>
+  <p:clrMapOvr>
+    <a:masterClrMapping/>
+  </p:clrMapOvr>
+</p:notes>
+</file>
+
+<file path=ppt/notesSlides/notesSlide10.xml><?xml version="1.0" encoding="utf-8"?>
+<p:notes xmlns:a="http://schemas.openxmlformats.org/drawingml/2006/main" xmlns:p="http://schemas.openxmlformats.org/presentationml/2006/main" xmlns:r="http://schemas.openxmlformats.org/officeDocument/2006/relationships">
+  <p:cSld>
+    <p:spTree>
+      <p:nvGrpSpPr>
+        <p:cNvPr id="1" name=""/>
+        <p:cNvGrpSpPr/>
+        <p:nvPr/>
+      </p:nvGrpSpPr>
+      <p:grpSpPr>
+        <a:xfrm>
+          <a:off x="0" y="0"/>
+          <a:ext cx="0" cy="0"/>
+          <a:chOff x="0" y="0"/>
+          <a:chExt cx="0" cy="0"/>
+        </a:xfrm>
+      </p:grpSpPr>
+      <p:sp>
+        <p:nvSpPr>
+          <p:cNvPr id="2" name="Slide Image Placeholder 1"/>
+          <p:cNvSpPr>
+            <a:spLocks noGrp="1"/>
+          </p:cNvSpPr>
+          <p:nvPr>
+            <p:ph type="sldImg" idx="2"/>
+          </p:nvPr>
+        </p:nvSpPr>
+        <p:spPr/>
+      </p:sp>
+      <p:sp>
+        <p:nvSpPr>
+          <p:cNvPr id="3" name="Notes Placeholder 2"/>
+          <p:cNvSpPr>
+            <a:spLocks noGrp="1"/>
+          </p:cNvSpPr>
+          <p:nvPr>
+            <p:ph type="body" idx="3" sz="quarter"/>
+          </p:nvPr>
+        </p:nvSpPr>
+        <p:spPr/>
+        <p:txBody>
+          <a:bodyPr/>
+          <a:lstStyle/>
+          <a:p>
+            <a:r>
+              <a:rPr b="1" sz="1300">
+                <a:latin typeface="Geist Mono"/>
+              </a:rPr>
+              <a:t>The headline number looks fine</a:t>
+            </a:r>
+          </a:p>
+          <a:p>
+            <a:r>
+              <a:rPr b="0" sz="1100">
+                <a:latin typeface="Geist"/>
+              </a:rPr>
+              <a:t>Overall the model scores about 68 percent -- unremarkable, the kind of number you would accept and move on. That is precisely the moment to stop and disaggregate. The next slide breaks this number apart by condition.</a:t>
+            </a:r>
+          </a:p>
+        </p:txBody>
+      </p:sp>
+      <p:sp>
+        <p:nvSpPr>
+          <p:cNvPr id="4" name="Slide Number Placeholder 3"/>
+          <p:cNvSpPr>
+            <a:spLocks noGrp="1"/>
+          </p:cNvSpPr>
+          <p:nvPr>
+            <p:ph type="sldNum" idx="5" sz="quarter"/>
+          </p:nvPr>
+        </p:nvSpPr>
+        <p:spPr/>
+      </p:sp>
+    </p:spTree>
+  </p:cSld>
+  <p:clrMapOvr>
+    <a:masterClrMapping/>
+  </p:clrMapOvr>
+</p:notes>
+</file>
+
+<file path=ppt/notesSlides/notesSlide11.xml><?xml version="1.0" encoding="utf-8"?>
+<p:notes xmlns:a="http://schemas.openxmlformats.org/drawingml/2006/main" xmlns:p="http://schemas.openxmlformats.org/presentationml/2006/main" xmlns:r="http://schemas.openxmlformats.org/officeDocument/2006/relationships">
+  <p:cSld>
+    <p:spTree>
+      <p:nvGrpSpPr>
+        <p:cNvPr id="1" name=""/>
+        <p:cNvGrpSpPr/>
+        <p:nvPr/>
+      </p:nvGrpSpPr>
+      <p:grpSpPr>
+        <a:xfrm>
+          <a:off x="0" y="0"/>
+          <a:ext cx="0" cy="0"/>
+          <a:chOff x="0" y="0"/>
+          <a:chExt cx="0" cy="0"/>
+        </a:xfrm>
+      </p:grpSpPr>
+      <p:sp>
+        <p:nvSpPr>
+          <p:cNvPr id="2" name="Slide Image Placeholder 1"/>
+          <p:cNvSpPr>
+            <a:spLocks noGrp="1"/>
+          </p:cNvSpPr>
+          <p:nvPr>
+            <p:ph type="sldImg" idx="2"/>
+          </p:nvPr>
+        </p:nvSpPr>
+        <p:spPr/>
+      </p:sp>
+      <p:sp>
+        <p:nvSpPr>
+          <p:cNvPr id="3" name="Notes Placeholder 2"/>
+          <p:cNvSpPr>
+            <a:spLocks noGrp="1"/>
+          </p:cNvSpPr>
+          <p:nvPr>
+            <p:ph type="body" idx="3" sz="quarter"/>
+          </p:nvPr>
+        </p:nvSpPr>
+        <p:spPr/>
+        <p:txBody>
+          <a:bodyPr/>
+          <a:lstStyle/>
+          <a:p>
+            <a:r>
+              <a:rPr b="1" sz="1300">
+                <a:latin typeface="Geist Mono"/>
+              </a:rPr>
+              <a:t>Break it apart: a whole condition is failed</a:t>
+            </a:r>
+          </a:p>
+          <a:p>
+            <a:r>
+              <a:rPr b="0" sz="1100">
+                <a:latin typeface="Geist"/>
+              </a:rPr>
+              <a:t>Splitting the 68 percent by condition exposes a near-total failure the average was hiding: common moles are caught about 99 percent of the time and prop the number up, while several rarer conditions are caught almost never, some at zero. The headline was carried almost entirely by one dominant class.</a:t>
+            </a:r>
+          </a:p>
+        </p:txBody>
+      </p:sp>
+      <p:sp>
+        <p:nvSpPr>
+          <p:cNvPr id="4" name="Slide Number Placeholder 3"/>
+          <p:cNvSpPr>
+            <a:spLocks noGrp="1"/>
+          </p:cNvSpPr>
+          <p:nvPr>
+            <p:ph type="sldNum" idx="5" sz="quarter"/>
+          </p:nvPr>
+        </p:nvSpPr>
+        <p:spPr/>
+      </p:sp>
+    </p:spTree>
+  </p:cSld>
+  <p:clrMapOvr>
+    <a:masterClrMapping/>
+  </p:clrMapOvr>
+</p:notes>
+</file>
+
+<file path=ppt/notesSlides/notesSlide12.xml><?xml version="1.0" encoding="utf-8"?>
+<p:notes xmlns:a="http://schemas.openxmlformats.org/drawingml/2006/main" xmlns:p="http://schemas.openxmlformats.org/presentationml/2006/main" xmlns:r="http://schemas.openxmlformats.org/officeDocument/2006/relationships">
+  <p:cSld>
+    <p:spTree>
+      <p:nvGrpSpPr>
+        <p:cNvPr id="1" name=""/>
+        <p:cNvGrpSpPr/>
+        <p:nvPr/>
+      </p:nvGrpSpPr>
+      <p:grpSpPr>
+        <a:xfrm>
+          <a:off x="0" y="0"/>
+          <a:ext cx="0" cy="0"/>
+          <a:chOff x="0" y="0"/>
+          <a:chExt cx="0" cy="0"/>
+        </a:xfrm>
+      </p:grpSpPr>
+      <p:sp>
+        <p:nvSpPr>
+          <p:cNvPr id="2" name="Slide Image Placeholder 1"/>
+          <p:cNvSpPr>
+            <a:spLocks noGrp="1"/>
+          </p:cNvSpPr>
+          <p:nvPr>
+            <p:ph type="sldImg" idx="2"/>
+          </p:nvPr>
+        </p:nvSpPr>
+        <p:spPr/>
+      </p:sp>
+      <p:sp>
+        <p:nvSpPr>
+          <p:cNvPr id="3" name="Notes Placeholder 2"/>
+          <p:cNvSpPr>
+            <a:spLocks noGrp="1"/>
+          </p:cNvSpPr>
+          <p:nvPr>
+            <p:ph type="body" idx="3" sz="quarter"/>
+          </p:nvPr>
+        </p:nvSpPr>
+        <p:spPr/>
+        <p:txBody>
+          <a:bodyPr/>
+          <a:lstStyle/>
+          <a:p>
+            <a:r>
+              <a:rPr b="1" sz="1300">
+                <a:latin typeface="Geist Mono"/>
+              </a:rPr>
+              <a:t>Why: the model sees some conditions far more</a:t>
+            </a:r>
+          </a:p>
+          <a:p>
+            <a:r>
+              <a:rPr b="0" sz="1100">
+                <a:latin typeface="Geist"/>
+              </a:rPr>
+              <a:t>The cause is simple: one class has thousands of training images while the rare conditions have only dozens, and a model gets best at whatever it sees most. This is the same imbalance the literature describes for skin tone -- shown here along the condition axis DermaMNIST records.</a:t>
+            </a:r>
+          </a:p>
+        </p:txBody>
+      </p:sp>
+      <p:sp>
+        <p:nvSpPr>
+          <p:cNvPr id="4" name="Slide Number Placeholder 3"/>
+          <p:cNvSpPr>
+            <a:spLocks noGrp="1"/>
+          </p:cNvSpPr>
+          <p:nvPr>
+            <p:ph type="sldNum" idx="5" sz="quarter"/>
+          </p:nvPr>
+        </p:nvSpPr>
+        <p:spPr/>
+      </p:sp>
+    </p:spTree>
+  </p:cSld>
+  <p:clrMapOvr>
+    <a:masterClrMapping/>
+  </p:clrMapOvr>
+</p:notes>
+</file>
+
+<file path=ppt/notesSlides/notesSlide13.xml><?xml version="1.0" encoding="utf-8"?>
+<p:notes xmlns:a="http://schemas.openxmlformats.org/drawingml/2006/main" xmlns:p="http://schemas.openxmlformats.org/presentationml/2006/main" xmlns:r="http://schemas.openxmlformats.org/officeDocument/2006/relationships">
+  <p:cSld>
+    <p:spTree>
+      <p:nvGrpSpPr>
+        <p:cNvPr id="1" name=""/>
+        <p:cNvGrpSpPr/>
+        <p:nvPr/>
+      </p:nvGrpSpPr>
+      <p:grpSpPr>
+        <a:xfrm>
+          <a:off x="0" y="0"/>
+          <a:ext cx="0" cy="0"/>
+          <a:chOff x="0" y="0"/>
+          <a:chExt cx="0" cy="0"/>
+        </a:xfrm>
+      </p:grpSpPr>
+      <p:sp>
+        <p:nvSpPr>
+          <p:cNvPr id="2" name="Slide Image Placeholder 1"/>
+          <p:cNvSpPr>
+            <a:spLocks noGrp="1"/>
+          </p:cNvSpPr>
+          <p:nvPr>
+            <p:ph type="sldImg" idx="2"/>
+          </p:nvPr>
+        </p:nvSpPr>
+        <p:spPr/>
+      </p:sp>
+      <p:sp>
+        <p:nvSpPr>
+          <p:cNvPr id="3" name="Notes Placeholder 2"/>
+          <p:cNvSpPr>
+            <a:spLocks noGrp="1"/>
+          </p:cNvSpPr>
+          <p:nvPr>
+            <p:ph type="body" idx="3" sz="quarter"/>
+          </p:nvPr>
+        </p:nvSpPr>
+        <p:spPr/>
+        <p:txBody>
+          <a:bodyPr/>
+          <a:lstStyle/>
+          <a:p>
+            <a:r>
+              <a:rPr b="1" sz="1300">
+                <a:latin typeface="Geist Mono"/>
+              </a:rPr>
+              <a:t>The blind spot we cannot measure</a:t>
+            </a:r>
+          </a:p>
+          <a:p>
+            <a:r>
+              <a:rPr b="0" sz="1100">
+                <a:latin typeface="Geist"/>
+              </a:rPr>
+              <a:t>The gap the literature worries about most is skin tone, but DermaMNIST ships no skin-tone labels -- only lesion type. So we can demonstrate the risk of a blind spot, not measure the real skin-tone gap. Saying that plainly is part of doing this honestly.</a:t>
+            </a:r>
+          </a:p>
+        </p:txBody>
+      </p:sp>
+      <p:sp>
+        <p:nvSpPr>
+          <p:cNvPr id="4" name="Slide Number Placeholder 3"/>
+          <p:cNvSpPr>
+            <a:spLocks noGrp="1"/>
+          </p:cNvSpPr>
+          <p:nvPr>
+            <p:ph type="sldNum" idx="5" sz="quarter"/>
+          </p:nvPr>
+        </p:nvSpPr>
+        <p:spPr/>
+      </p:sp>
+    </p:spTree>
+  </p:cSld>
+  <p:clrMapOvr>
+    <a:masterClrMapping/>
+  </p:clrMapOvr>
+</p:notes>
+</file>
+
+<file path=ppt/notesSlides/notesSlide14.xml><?xml version="1.0" encoding="utf-8"?>
+<p:notes xmlns:a="http://schemas.openxmlformats.org/drawingml/2006/main" xmlns:p="http://schemas.openxmlformats.org/presentationml/2006/main" xmlns:r="http://schemas.openxmlformats.org/officeDocument/2006/relationships">
+  <p:cSld>
+    <p:spTree>
+      <p:nvGrpSpPr>
+        <p:cNvPr id="1" name=""/>
+        <p:cNvGrpSpPr/>
+        <p:nvPr/>
+      </p:nvGrpSpPr>
+      <p:grpSpPr>
+        <a:xfrm>
+          <a:off x="0" y="0"/>
+          <a:ext cx="0" cy="0"/>
+          <a:chOff x="0" y="0"/>
+          <a:chExt cx="0" cy="0"/>
+        </a:xfrm>
+      </p:grpSpPr>
+      <p:sp>
+        <p:nvSpPr>
+          <p:cNvPr id="2" name="Slide Image Placeholder 1"/>
+          <p:cNvSpPr>
+            <a:spLocks noGrp="1"/>
+          </p:cNvSpPr>
+          <p:nvPr>
+            <p:ph type="sldImg" idx="2"/>
+          </p:nvPr>
+        </p:nvSpPr>
+        <p:spPr/>
+      </p:sp>
+      <p:sp>
+        <p:nvSpPr>
+          <p:cNvPr id="3" name="Notes Placeholder 2"/>
+          <p:cNvSpPr>
+            <a:spLocks noGrp="1"/>
+          </p:cNvSpPr>
+          <p:nvPr>
+            <p:ph type="body" idx="3" sz="quarter"/>
+          </p:nvPr>
+        </p:nvSpPr>
+        <p:spPr/>
+        <p:txBody>
+          <a:bodyPr/>
+          <a:lstStyle/>
+          <a:p>
+            <a:r>
+              <a:rPr b="1" sz="1300">
+                <a:latin typeface="Geist Mono"/>
+              </a:rPr>
+              <a:t>Being honest</a:t>
+            </a:r>
+          </a:p>
+          <a:p>
+            <a:r>
+              <a:rPr b="0" sz="1100">
+                <a:latin typeface="Geist"/>
+              </a:rPr>
+              <a:t>This closing section is about honesty: naming who the tool leaves out, and admitting what our dataset cannot tell us. Model the habit of stating limits out loud.</a:t>
+            </a:r>
+          </a:p>
+        </p:txBody>
+      </p:sp>
+      <p:sp>
+        <p:nvSpPr>
+          <p:cNvPr id="4" name="Slide Number Placeholder 3"/>
+          <p:cNvSpPr>
+            <a:spLocks noGrp="1"/>
+          </p:cNvSpPr>
+          <p:nvPr>
+            <p:ph type="sldNum" idx="5" sz="quarter"/>
+          </p:nvPr>
+        </p:nvSpPr>
+        <p:spPr/>
+      </p:sp>
+    </p:spTree>
+  </p:cSld>
+  <p:clrMapOvr>
+    <a:masterClrMapping/>
+  </p:clrMapOvr>
+</p:notes>
+</file>
+
+<file path=ppt/notesSlides/notesSlide15.xml><?xml version="1.0" encoding="utf-8"?>
+<p:notes xmlns:a="http://schemas.openxmlformats.org/drawingml/2006/main" xmlns:p="http://schemas.openxmlformats.org/presentationml/2006/main" xmlns:r="http://schemas.openxmlformats.org/officeDocument/2006/relationships">
+  <p:cSld>
+    <p:spTree>
+      <p:nvGrpSpPr>
+        <p:cNvPr id="1" name=""/>
+        <p:cNvGrpSpPr/>
+        <p:nvPr/>
+      </p:nvGrpSpPr>
+      <p:grpSpPr>
+        <a:xfrm>
+          <a:off x="0" y="0"/>
+          <a:ext cx="0" cy="0"/>
+          <a:chOff x="0" y="0"/>
+          <a:chExt cx="0" cy="0"/>
+        </a:xfrm>
+      </p:grpSpPr>
+      <p:sp>
+        <p:nvSpPr>
+          <p:cNvPr id="2" name="Slide Image Placeholder 1"/>
+          <p:cNvSpPr>
+            <a:spLocks noGrp="1"/>
+          </p:cNvSpPr>
+          <p:nvPr>
+            <p:ph type="sldImg" idx="2"/>
+          </p:nvPr>
+        </p:nvSpPr>
+        <p:spPr/>
+      </p:sp>
+      <p:sp>
+        <p:nvSpPr>
+          <p:cNvPr id="3" name="Notes Placeholder 2"/>
+          <p:cNvSpPr>
+            <a:spLocks noGrp="1"/>
+          </p:cNvSpPr>
+          <p:nvPr>
+            <p:ph type="body" idx="3" sz="quarter"/>
+          </p:nvPr>
+        </p:nvSpPr>
+        <p:spPr/>
+        <p:txBody>
+          <a:bodyPr/>
+          <a:lstStyle/>
+          <a:p>
+            <a:r>
+              <a:rPr b="1" sz="1300">
+                <a:latin typeface="Geist Mono"/>
+              </a:rPr>
+              <a:t>Who gets left out</a:t>
+            </a:r>
+          </a:p>
+          <a:p>
+            <a:r>
+              <a:rPr b="0" sz="1100">
+                <a:latin typeface="Geist"/>
+              </a:rPr>
+              <a:t>The cruel irony: the people the pitch was meant to help -- those with little access, often in underrepresented regions and skin types -- are the ones most likely missing from the training data. A tool that works worst where care is scarcest can widen the very gap it was sold to close.</a:t>
+            </a:r>
+          </a:p>
+        </p:txBody>
+      </p:sp>
+      <p:sp>
+        <p:nvSpPr>
+          <p:cNvPr id="4" name="Slide Number Placeholder 3"/>
+          <p:cNvSpPr>
+            <a:spLocks noGrp="1"/>
+          </p:cNvSpPr>
+          <p:nvPr>
+            <p:ph type="sldNum" idx="5" sz="quarter"/>
+          </p:nvPr>
+        </p:nvSpPr>
+        <p:spPr/>
+      </p:sp>
+    </p:spTree>
+  </p:cSld>
+  <p:clrMapOvr>
+    <a:masterClrMapping/>
+  </p:clrMapOvr>
+</p:notes>
+</file>
+
+<file path=ppt/notesSlides/notesSlide16.xml><?xml version="1.0" encoding="utf-8"?>
+<p:notes xmlns:a="http://schemas.openxmlformats.org/drawingml/2006/main" xmlns:p="http://schemas.openxmlformats.org/presentationml/2006/main" xmlns:r="http://schemas.openxmlformats.org/officeDocument/2006/relationships">
+  <p:cSld>
+    <p:spTree>
+      <p:nvGrpSpPr>
+        <p:cNvPr id="1" name=""/>
+        <p:cNvGrpSpPr/>
+        <p:nvPr/>
+      </p:nvGrpSpPr>
+      <p:grpSpPr>
+        <a:xfrm>
+          <a:off x="0" y="0"/>
+          <a:ext cx="0" cy="0"/>
+          <a:chOff x="0" y="0"/>
+          <a:chExt cx="0" cy="0"/>
+        </a:xfrm>
+      </p:grpSpPr>
+      <p:sp>
+        <p:nvSpPr>
+          <p:cNvPr id="2" name="Slide Image Placeholder 1"/>
+          <p:cNvSpPr>
+            <a:spLocks noGrp="1"/>
+          </p:cNvSpPr>
+          <p:nvPr>
+            <p:ph type="sldImg" idx="2"/>
+          </p:nvPr>
+        </p:nvSpPr>
+        <p:spPr/>
+      </p:sp>
+      <p:sp>
+        <p:nvSpPr>
+          <p:cNvPr id="3" name="Notes Placeholder 2"/>
+          <p:cNvSpPr>
+            <a:spLocks noGrp="1"/>
+          </p:cNvSpPr>
+          <p:nvPr>
+            <p:ph type="body" idx="3" sz="quarter"/>
+          </p:nvPr>
+        </p:nvSpPr>
+        <p:spPr/>
+        <p:txBody>
+          <a:bodyPr/>
+          <a:lstStyle/>
+          <a:p>
+            <a:r>
+              <a:rPr b="1" sz="1300">
+                <a:latin typeface="Geist Mono"/>
+              </a:rPr>
+              <a:t>References</a:t>
+            </a:r>
+          </a:p>
+          <a:p>
+            <a:r>
+              <a:rPr b="0" sz="1100">
+                <a:latin typeface="Geist"/>
+              </a:rPr>
+              <a:t>These seven papers anchor the equity lens, from the Fitzpatrick scale that names the skin-type groups, to the studies that measured the accuracy gaps, to Obermeyer's proxy-bias case. Point students here for the primary sources.</a:t>
+            </a:r>
+          </a:p>
+        </p:txBody>
+      </p:sp>
+      <p:sp>
+        <p:nvSpPr>
+          <p:cNvPr id="4" name="Slide Number Placeholder 3"/>
+          <p:cNvSpPr>
+            <a:spLocks noGrp="1"/>
+          </p:cNvSpPr>
+          <p:nvPr>
+            <p:ph type="sldNum" idx="5" sz="quarter"/>
+          </p:nvPr>
+        </p:nvSpPr>
+        <p:spPr/>
+      </p:sp>
+    </p:spTree>
+  </p:cSld>
+  <p:clrMapOvr>
+    <a:masterClrMapping/>
+  </p:clrMapOvr>
+</p:notes>
+</file>
+
+<file path=ppt/notesSlides/notesSlide2.xml><?xml version="1.0" encoding="utf-8"?>
+<p:notes xmlns:a="http://schemas.openxmlformats.org/drawingml/2006/main" xmlns:p="http://schemas.openxmlformats.org/presentationml/2006/main" xmlns:r="http://schemas.openxmlformats.org/officeDocument/2006/relationships">
+  <p:cSld>
+    <p:spTree>
+      <p:nvGrpSpPr>
+        <p:cNvPr id="1" name=""/>
+        <p:cNvGrpSpPr/>
+        <p:nvPr/>
+      </p:nvGrpSpPr>
+      <p:grpSpPr>
+        <a:xfrm>
+          <a:off x="0" y="0"/>
+          <a:ext cx="0" cy="0"/>
+          <a:chOff x="0" y="0"/>
+          <a:chExt cx="0" cy="0"/>
+        </a:xfrm>
+      </p:grpSpPr>
+      <p:sp>
+        <p:nvSpPr>
+          <p:cNvPr id="2" name="Slide Image Placeholder 1"/>
+          <p:cNvSpPr>
+            <a:spLocks noGrp="1"/>
+          </p:cNvSpPr>
+          <p:nvPr>
+            <p:ph type="sldImg" idx="2"/>
+          </p:nvPr>
+        </p:nvSpPr>
+        <p:spPr/>
+      </p:sp>
+      <p:sp>
+        <p:nvSpPr>
+          <p:cNvPr id="3" name="Notes Placeholder 2"/>
+          <p:cNvSpPr>
+            <a:spLocks noGrp="1"/>
+          </p:cNvSpPr>
+          <p:nvPr>
+            <p:ph type="body" idx="3" sz="quarter"/>
+          </p:nvPr>
+        </p:nvSpPr>
+        <p:spPr/>
+        <p:txBody>
+          <a:bodyPr/>
+          <a:lstStyle/>
+          <a:p>
+            <a:r>
+              <a:rPr b="1" sz="1300">
+                <a:latin typeface="Geist Mono"/>
+              </a:rPr>
+              <a:t>A promise, and a catch</a:t>
+            </a:r>
+          </a:p>
+          <a:p>
+            <a:r>
+              <a:rPr b="0" sz="1100">
+                <a:latin typeface="Geist"/>
+              </a:rPr>
+              <a:t>Skin-cancer AI could reach billions who never see a dermatologist, but a model only knows what its training images showed it, and those images skew heavily toward light skin. The promise and the risk are two sides of the same coin. Next we look at what the training data actually contains.</a:t>
+            </a:r>
+          </a:p>
+        </p:txBody>
+      </p:sp>
+      <p:sp>
+        <p:nvSpPr>
+          <p:cNvPr id="4" name="Slide Number Placeholder 3"/>
+          <p:cNvSpPr>
+            <a:spLocks noGrp="1"/>
+          </p:cNvSpPr>
+          <p:nvPr>
+            <p:ph type="sldNum" idx="5" sz="quarter"/>
+          </p:nvPr>
+        </p:nvSpPr>
+        <p:spPr/>
+      </p:sp>
+    </p:spTree>
+  </p:cSld>
+  <p:clrMapOvr>
+    <a:masterClrMapping/>
+  </p:clrMapOvr>
+</p:notes>
+</file>
+
+<file path=ppt/notesSlides/notesSlide3.xml><?xml version="1.0" encoding="utf-8"?>
+<p:notes xmlns:a="http://schemas.openxmlformats.org/drawingml/2006/main" xmlns:p="http://schemas.openxmlformats.org/presentationml/2006/main" xmlns:r="http://schemas.openxmlformats.org/officeDocument/2006/relationships">
+  <p:cSld>
+    <p:spTree>
+      <p:nvGrpSpPr>
+        <p:cNvPr id="1" name=""/>
+        <p:cNvGrpSpPr/>
+        <p:nvPr/>
+      </p:nvGrpSpPr>
+      <p:grpSpPr>
+        <a:xfrm>
+          <a:off x="0" y="0"/>
+          <a:ext cx="0" cy="0"/>
+          <a:chOff x="0" y="0"/>
+          <a:chExt cx="0" cy="0"/>
+        </a:xfrm>
+      </p:grpSpPr>
+      <p:sp>
+        <p:nvSpPr>
+          <p:cNvPr id="2" name="Slide Image Placeholder 1"/>
+          <p:cNvSpPr>
+            <a:spLocks noGrp="1"/>
+          </p:cNvSpPr>
+          <p:nvPr>
+            <p:ph type="sldImg" idx="2"/>
+          </p:nvPr>
+        </p:nvSpPr>
+        <p:spPr/>
+      </p:sp>
+      <p:sp>
+        <p:nvSpPr>
+          <p:cNvPr id="3" name="Notes Placeholder 2"/>
+          <p:cNvSpPr>
+            <a:spLocks noGrp="1"/>
+          </p:cNvSpPr>
+          <p:nvPr>
+            <p:ph type="body" idx="3" sz="quarter"/>
+          </p:nvPr>
+        </p:nvSpPr>
+        <p:spPr/>
+        <p:txBody>
+          <a:bodyPr/>
+          <a:lstStyle/>
+          <a:p>
+            <a:r>
+              <a:rPr b="1" sz="1300">
+                <a:latin typeface="Geist Mono"/>
+              </a:rPr>
+              <a:t>The AI mostly practiced on light skin</a:t>
+            </a:r>
+          </a:p>
+          <a:p>
+            <a:r>
+              <a:rPr b="0" sz="1100">
+                <a:latin typeface="Geist"/>
+              </a:rPr>
+              <a:t>A systematic review of 21 public skin datasets (over 100,000 images) found almost all came from light-skinned patients in Europe, North America, and Oceania. On the Fitzpatrick I-VI scale the counts pile up on the lighter types and nearly vanish on the darker ones. A model that barely sees dark skin in training has little chance of doing well on it.</a:t>
+            </a:r>
+          </a:p>
+        </p:txBody>
+      </p:sp>
+      <p:sp>
+        <p:nvSpPr>
+          <p:cNvPr id="4" name="Slide Number Placeholder 3"/>
+          <p:cNvSpPr>
+            <a:spLocks noGrp="1"/>
+          </p:cNvSpPr>
+          <p:nvPr>
+            <p:ph type="sldNum" idx="5" sz="quarter"/>
+          </p:nvPr>
+        </p:nvSpPr>
+        <p:spPr/>
+      </p:sp>
+    </p:spTree>
+  </p:cSld>
+  <p:clrMapOvr>
+    <a:masterClrMapping/>
+  </p:clrMapOvr>
+</p:notes>
+</file>
+
+<file path=ppt/notesSlides/notesSlide4.xml><?xml version="1.0" encoding="utf-8"?>
+<p:notes xmlns:a="http://schemas.openxmlformats.org/drawingml/2006/main" xmlns:p="http://schemas.openxmlformats.org/presentationml/2006/main" xmlns:r="http://schemas.openxmlformats.org/officeDocument/2006/relationships">
+  <p:cSld>
+    <p:spTree>
+      <p:nvGrpSpPr>
+        <p:cNvPr id="1" name=""/>
+        <p:cNvGrpSpPr/>
+        <p:nvPr/>
+      </p:nvGrpSpPr>
+      <p:grpSpPr>
+        <a:xfrm>
+          <a:off x="0" y="0"/>
+          <a:ext cx="0" cy="0"/>
+          <a:chOff x="0" y="0"/>
+          <a:chExt cx="0" cy="0"/>
+        </a:xfrm>
+      </p:grpSpPr>
+      <p:sp>
+        <p:nvSpPr>
+          <p:cNvPr id="2" name="Slide Image Placeholder 1"/>
+          <p:cNvSpPr>
+            <a:spLocks noGrp="1"/>
+          </p:cNvSpPr>
+          <p:nvPr>
+            <p:ph type="sldImg" idx="2"/>
+          </p:nvPr>
+        </p:nvSpPr>
+        <p:spPr/>
+      </p:sp>
+      <p:sp>
+        <p:nvSpPr>
+          <p:cNvPr id="3" name="Notes Placeholder 2"/>
+          <p:cNvSpPr>
+            <a:spLocks noGrp="1"/>
+          </p:cNvSpPr>
+          <p:nvPr>
+            <p:ph type="body" idx="3" sz="quarter"/>
+          </p:nvPr>
+        </p:nvSpPr>
+        <p:spPr/>
+        <p:txBody>
+          <a:bodyPr/>
+          <a:lstStyle/>
+          <a:p>
+            <a:r>
+              <a:rPr b="1" sz="1300">
+                <a:latin typeface="Geist Mono"/>
+              </a:rPr>
+              <a:t>Same model, one number hides who it fails</a:t>
+            </a:r>
+          </a:p>
+          <a:p>
+            <a:r>
+              <a:rPr b="0" sz="1100">
+                <a:latin typeface="Geist"/>
+              </a:rPr>
+              <a:t>Two studies make the point: Groh showed a model is most accurate on the skin types it saw most, and Daneshjou showed top models drop sharply on dark skin. The single average accuracy a report cites sits between the groups and hides the gap. This is why we distrust one headline number.</a:t>
+            </a:r>
+          </a:p>
+        </p:txBody>
+      </p:sp>
+      <p:sp>
+        <p:nvSpPr>
+          <p:cNvPr id="4" name="Slide Number Placeholder 3"/>
+          <p:cNvSpPr>
+            <a:spLocks noGrp="1"/>
+          </p:cNvSpPr>
+          <p:nvPr>
+            <p:ph type="sldNum" idx="5" sz="quarter"/>
+          </p:nvPr>
+        </p:nvSpPr>
+        <p:spPr/>
+      </p:sp>
+    </p:spTree>
+  </p:cSld>
+  <p:clrMapOvr>
+    <a:masterClrMapping/>
+  </p:clrMapOvr>
+</p:notes>
+</file>
+
+<file path=ppt/notesSlides/notesSlide5.xml><?xml version="1.0" encoding="utf-8"?>
+<p:notes xmlns:a="http://schemas.openxmlformats.org/drawingml/2006/main" xmlns:p="http://schemas.openxmlformats.org/presentationml/2006/main" xmlns:r="http://schemas.openxmlformats.org/officeDocument/2006/relationships">
+  <p:cSld>
+    <p:spTree>
+      <p:nvGrpSpPr>
+        <p:cNvPr id="1" name=""/>
+        <p:cNvGrpSpPr/>
+        <p:nvPr/>
+      </p:nvGrpSpPr>
+      <p:grpSpPr>
+        <a:xfrm>
+          <a:off x="0" y="0"/>
+          <a:ext cx="0" cy="0"/>
+          <a:chOff x="0" y="0"/>
+          <a:chExt cx="0" cy="0"/>
+        </a:xfrm>
+      </p:grpSpPr>
+      <p:sp>
+        <p:nvSpPr>
+          <p:cNvPr id="2" name="Slide Image Placeholder 1"/>
+          <p:cNvSpPr>
+            <a:spLocks noGrp="1"/>
+          </p:cNvSpPr>
+          <p:nvPr>
+            <p:ph type="sldImg" idx="2"/>
+          </p:nvPr>
+        </p:nvSpPr>
+        <p:spPr/>
+      </p:sp>
+      <p:sp>
+        <p:nvSpPr>
+          <p:cNvPr id="3" name="Notes Placeholder 2"/>
+          <p:cNvSpPr>
+            <a:spLocks noGrp="1"/>
+          </p:cNvSpPr>
+          <p:nvPr>
+            <p:ph type="body" idx="3" sz="quarter"/>
+          </p:nvPr>
+        </p:nvSpPr>
+        <p:spPr/>
+        <p:txBody>
+          <a:bodyPr/>
+          <a:lstStyle/>
+          <a:p>
+            <a:r>
+              <a:rPr b="1" sz="1300">
+                <a:latin typeface="Geist Mono"/>
+              </a:rPr>
+              <a:t>Accurate on average can still be unfair</a:t>
+            </a:r>
+          </a:p>
+          <a:p>
+            <a:r>
+              <a:rPr b="0" sz="1100">
+                <a:latin typeface="Geist"/>
+              </a:rPr>
+              <a:t>Obermeyer's famous case: a health algorithm used on millions looked fair on average but underserved Black patients, because it predicted cost as a stand-in for illness -- the wrong target. A model can score well and still be unfair. That is exactly the suspicion we carry into our own model.</a:t>
+            </a:r>
+          </a:p>
+        </p:txBody>
+      </p:sp>
+      <p:sp>
+        <p:nvSpPr>
+          <p:cNvPr id="4" name="Slide Number Placeholder 3"/>
+          <p:cNvSpPr>
+            <a:spLocks noGrp="1"/>
+          </p:cNvSpPr>
+          <p:nvPr>
+            <p:ph type="sldNum" idx="5" sz="quarter"/>
+          </p:nvPr>
+        </p:nvSpPr>
+        <p:spPr/>
+      </p:sp>
+    </p:spTree>
+  </p:cSld>
+  <p:clrMapOvr>
+    <a:masterClrMapping/>
+  </p:clrMapOvr>
+</p:notes>
+</file>
+
+<file path=ppt/notesSlides/notesSlide6.xml><?xml version="1.0" encoding="utf-8"?>
+<p:notes xmlns:a="http://schemas.openxmlformats.org/drawingml/2006/main" xmlns:p="http://schemas.openxmlformats.org/presentationml/2006/main" xmlns:r="http://schemas.openxmlformats.org/officeDocument/2006/relationships">
+  <p:cSld>
+    <p:spTree>
+      <p:nvGrpSpPr>
+        <p:cNvPr id="1" name=""/>
+        <p:cNvGrpSpPr/>
+        <p:nvPr/>
+      </p:nvGrpSpPr>
+      <p:grpSpPr>
+        <a:xfrm>
+          <a:off x="0" y="0"/>
+          <a:ext cx="0" cy="0"/>
+          <a:chOff x="0" y="0"/>
+          <a:chExt cx="0" cy="0"/>
+        </a:xfrm>
+      </p:grpSpPr>
+      <p:sp>
+        <p:nvSpPr>
+          <p:cNvPr id="2" name="Slide Image Placeholder 1"/>
+          <p:cNvSpPr>
+            <a:spLocks noGrp="1"/>
+          </p:cNvSpPr>
+          <p:nvPr>
+            <p:ph type="sldImg" idx="2"/>
+          </p:nvPr>
+        </p:nvSpPr>
+        <p:spPr/>
+      </p:sp>
+      <p:sp>
+        <p:nvSpPr>
+          <p:cNvPr id="3" name="Notes Placeholder 2"/>
+          <p:cNvSpPr>
+            <a:spLocks noGrp="1"/>
+          </p:cNvSpPr>
+          <p:nvPr>
+            <p:ph type="body" idx="3" sz="quarter"/>
+          </p:nvPr>
+        </p:nvSpPr>
+        <p:spPr/>
+        <p:txBody>
+          <a:bodyPr/>
+          <a:lstStyle/>
+          <a:p>
+            <a:r>
+              <a:rPr b="1" sz="1300">
+                <a:latin typeface="Geist Mono"/>
+              </a:rPr>
+              <a:t>Methods</a:t>
+            </a:r>
+          </a:p>
+          <a:p>
+            <a:r>
+              <a:rPr b="0" sz="1100">
+                <a:latin typeface="Geist"/>
+              </a:rPr>
+              <a:t>Here we explain what we actually did. The key move is that we reuse the screening group's exact model and change only the question we ask of it -- from 'how accurate?' to 'accurate for whom?'.</a:t>
+            </a:r>
+          </a:p>
+        </p:txBody>
+      </p:sp>
+      <p:sp>
+        <p:nvSpPr>
+          <p:cNvPr id="4" name="Slide Number Placeholder 3"/>
+          <p:cNvSpPr>
+            <a:spLocks noGrp="1"/>
+          </p:cNvSpPr>
+          <p:nvPr>
+            <p:ph type="sldNum" idx="5" sz="quarter"/>
+          </p:nvPr>
+        </p:nvSpPr>
+        <p:spPr/>
+      </p:sp>
+    </p:spTree>
+  </p:cSld>
+  <p:clrMapOvr>
+    <a:masterClrMapping/>
+  </p:clrMapOvr>
+</p:notes>
+</file>
+
+<file path=ppt/notesSlides/notesSlide7.xml><?xml version="1.0" encoding="utf-8"?>
+<p:notes xmlns:a="http://schemas.openxmlformats.org/drawingml/2006/main" xmlns:p="http://schemas.openxmlformats.org/presentationml/2006/main" xmlns:r="http://schemas.openxmlformats.org/officeDocument/2006/relationships">
+  <p:cSld>
+    <p:spTree>
+      <p:nvGrpSpPr>
+        <p:cNvPr id="1" name=""/>
+        <p:cNvGrpSpPr/>
+        <p:nvPr/>
+      </p:nvGrpSpPr>
+      <p:grpSpPr>
+        <a:xfrm>
+          <a:off x="0" y="0"/>
+          <a:ext cx="0" cy="0"/>
+          <a:chOff x="0" y="0"/>
+          <a:chExt cx="0" cy="0"/>
+        </a:xfrm>
+      </p:grpSpPr>
+      <p:sp>
+        <p:nvSpPr>
+          <p:cNvPr id="2" name="Slide Image Placeholder 1"/>
+          <p:cNvSpPr>
+            <a:spLocks noGrp="1"/>
+          </p:cNvSpPr>
+          <p:nvPr>
+            <p:ph type="sldImg" idx="2"/>
+          </p:nvPr>
+        </p:nvSpPr>
+        <p:spPr/>
+      </p:sp>
+      <p:sp>
+        <p:nvSpPr>
+          <p:cNvPr id="3" name="Notes Placeholder 2"/>
+          <p:cNvSpPr>
+            <a:spLocks noGrp="1"/>
+          </p:cNvSpPr>
+          <p:nvPr>
+            <p:ph type="body" idx="3" sz="quarter"/>
+          </p:nvPr>
+        </p:nvSpPr>
+        <p:spPr/>
+        <p:txBody>
+          <a:bodyPr/>
+          <a:lstStyle/>
+          <a:p>
+            <a:r>
+              <a:rPr b="1" sz="1300">
+                <a:latin typeface="Geist Mono"/>
+              </a:rPr>
+              <a:t>The same model, a harder question</a:t>
+            </a:r>
+          </a:p>
+          <a:p>
+            <a:r>
+              <a:rPr b="0" sz="1100">
+                <a:latin typeface="Geist"/>
+              </a:rPr>
+              <a:t>We deliberately keep the screening group's model unchanged -- a ResNet18 with a fresh head sorting images into seven conditions -- so the only variable is the question. Same tool, harder question: not 'is it good?' but 'good for whom?'.</a:t>
+            </a:r>
+          </a:p>
+        </p:txBody>
+      </p:sp>
+      <p:sp>
+        <p:nvSpPr>
+          <p:cNvPr id="4" name="Slide Number Placeholder 3"/>
+          <p:cNvSpPr>
+            <a:spLocks noGrp="1"/>
+          </p:cNvSpPr>
+          <p:nvPr>
+            <p:ph type="sldNum" idx="5" sz="quarter"/>
+          </p:nvPr>
+        </p:nvSpPr>
+        <p:spPr/>
+      </p:sp>
+    </p:spTree>
+  </p:cSld>
+  <p:clrMapOvr>
+    <a:masterClrMapping/>
+  </p:clrMapOvr>
+</p:notes>
+</file>
+
+<file path=ppt/notesSlides/notesSlide8.xml><?xml version="1.0" encoding="utf-8"?>
+<p:notes xmlns:a="http://schemas.openxmlformats.org/drawingml/2006/main" xmlns:p="http://schemas.openxmlformats.org/presentationml/2006/main" xmlns:r="http://schemas.openxmlformats.org/officeDocument/2006/relationships">
+  <p:cSld>
+    <p:spTree>
+      <p:nvGrpSpPr>
+        <p:cNvPr id="1" name=""/>
+        <p:cNvGrpSpPr/>
+        <p:nvPr/>
+      </p:nvGrpSpPr>
+      <p:grpSpPr>
+        <a:xfrm>
+          <a:off x="0" y="0"/>
+          <a:ext cx="0" cy="0"/>
+          <a:chOff x="0" y="0"/>
+          <a:chExt cx="0" cy="0"/>
+        </a:xfrm>
+      </p:grpSpPr>
+      <p:sp>
+        <p:nvSpPr>
+          <p:cNvPr id="2" name="Slide Image Placeholder 1"/>
+          <p:cNvSpPr>
+            <a:spLocks noGrp="1"/>
+          </p:cNvSpPr>
+          <p:nvPr>
+            <p:ph type="sldImg" idx="2"/>
+          </p:nvPr>
+        </p:nvSpPr>
+        <p:spPr/>
+      </p:sp>
+      <p:sp>
+        <p:nvSpPr>
+          <p:cNvPr id="3" name="Notes Placeholder 2"/>
+          <p:cNvSpPr>
+            <a:spLocks noGrp="1"/>
+          </p:cNvSpPr>
+          <p:nvPr>
+            <p:ph type="body" idx="3" sz="quarter"/>
+          </p:nvPr>
+        </p:nvSpPr>
+        <p:spPr/>
+        <p:txBody>
+          <a:bodyPr/>
+          <a:lstStyle/>
+          <a:p>
+            <a:r>
+              <a:rPr b="1" sz="1300">
+                <a:latin typeface="Geist Mono"/>
+              </a:rPr>
+              <a:t>The equity lens: break the average apart</a:t>
+            </a:r>
+          </a:p>
+          <a:p>
+            <a:r>
+              <a:rPr b="0" sz="1100">
+                <a:latin typeface="Geist"/>
+              </a:rPr>
+              <a:t>A single accuracy number is an average, and an average can let one strong group carry a failing one. The equity lens refuses the blend and splits the score apart. Here we split by condition, because that is the axis DermaMNIST actually labels.</a:t>
+            </a:r>
+          </a:p>
+        </p:txBody>
+      </p:sp>
+      <p:sp>
+        <p:nvSpPr>
+          <p:cNvPr id="4" name="Slide Number Placeholder 3"/>
+          <p:cNvSpPr>
+            <a:spLocks noGrp="1"/>
+          </p:cNvSpPr>
+          <p:nvPr>
+            <p:ph type="sldNum" idx="5" sz="quarter"/>
+          </p:nvPr>
+        </p:nvSpPr>
+        <p:spPr/>
+      </p:sp>
+    </p:spTree>
+  </p:cSld>
+  <p:clrMapOvr>
+    <a:masterClrMapping/>
+  </p:clrMapOvr>
+</p:notes>
+</file>
+
+<file path=ppt/notesSlides/notesSlide9.xml><?xml version="1.0" encoding="utf-8"?>
+<p:notes xmlns:a="http://schemas.openxmlformats.org/drawingml/2006/main" xmlns:p="http://schemas.openxmlformats.org/presentationml/2006/main" xmlns:r="http://schemas.openxmlformats.org/officeDocument/2006/relationships">
+  <p:cSld>
+    <p:spTree>
+      <p:nvGrpSpPr>
+        <p:cNvPr id="1" name=""/>
+        <p:cNvGrpSpPr/>
+        <p:nvPr/>
+      </p:nvGrpSpPr>
+      <p:grpSpPr>
+        <a:xfrm>
+          <a:off x="0" y="0"/>
+          <a:ext cx="0" cy="0"/>
+          <a:chOff x="0" y="0"/>
+          <a:chExt cx="0" cy="0"/>
+        </a:xfrm>
+      </p:grpSpPr>
+      <p:sp>
+        <p:nvSpPr>
+          <p:cNvPr id="2" name="Slide Image Placeholder 1"/>
+          <p:cNvSpPr>
+            <a:spLocks noGrp="1"/>
+          </p:cNvSpPr>
+          <p:nvPr>
+            <p:ph type="sldImg" idx="2"/>
+          </p:nvPr>
+        </p:nvSpPr>
+        <p:spPr/>
+      </p:sp>
+      <p:sp>
+        <p:nvSpPr>
+          <p:cNvPr id="3" name="Notes Placeholder 2"/>
+          <p:cNvSpPr>
+            <a:spLocks noGrp="1"/>
+          </p:cNvSpPr>
+          <p:nvPr>
+            <p:ph type="body" idx="3" sz="quarter"/>
+          </p:nvPr>
+        </p:nvSpPr>
+        <p:spPr/>
+        <p:txBody>
+          <a:bodyPr/>
+          <a:lstStyle/>
+          <a:p>
+            <a:r>
+              <a:rPr b="1" sz="1300">
+                <a:latin typeface="Geist Mono"/>
+              </a:rPr>
+              <a:t>Results</a:t>
+            </a:r>
+          </a:p>
+          <a:p>
+            <a:r>
+              <a:rPr b="0" sz="1100">
+                <a:latin typeface="Geist"/>
+              </a:rPr>
+              <a:t>Now we show what breaking the average apart reveals. Watch for the gap between the single headline number and the per-condition scores hiding beneath it.</a:t>
+            </a:r>
+          </a:p>
+        </p:txBody>
+      </p:sp>
+      <p:sp>
+        <p:nvSpPr>
+          <p:cNvPr id="4" name="Slide Number Placeholder 3"/>
+          <p:cNvSpPr>
+            <a:spLocks noGrp="1"/>
+          </p:cNvSpPr>
+          <p:nvPr>
+            <p:ph type="sldNum" idx="5" sz="quarter"/>
+          </p:nvPr>
+        </p:nvSpPr>
+        <p:spPr/>
+      </p:sp>
+    </p:spTree>
+  </p:cSld>
+  <p:clrMapOvr>
+    <a:masterClrMapping/>
+  </p:clrMapOvr>
+</p:notes>
 </file>
 
 <file path=ppt/slideLayouts/slideLayout1.xml><?xml version="1.0" encoding="utf-8"?>
@@ -4222,8 +5868,8 @@
         </p:nvSpPr>
         <p:spPr>
           <a:xfrm>
-            <a:off x="548640" y="1234440"/>
-            <a:ext cx="11064240" cy="694944"/>
+            <a:off x="457200" y="1371600"/>
+            <a:ext cx="5852160" cy="1737360"/>
           </a:xfrm>
           <a:prstGeom prst="rect">
             <a:avLst/>
@@ -4238,13 +5884,162 @@
           <a:p>
             <a:pPr algn="l"/>
             <a:r>
-              <a:rPr sz="1400" b="0" i="0">
+              <a:rPr sz="12000" b="1" i="0">
+                <a:solidFill>
+                  <a:srgbClr val="14141C"/>
+                </a:solidFill>
+                <a:latin typeface="Geist Mono"/>
+              </a:rPr>
+              <a:t>68%</a:t>
+            </a:r>
+          </a:p>
+        </p:txBody>
+      </p:sp>
+      <p:sp>
+        <p:nvSpPr>
+          <p:cNvPr id="8" name="TextBox 7"/>
+          <p:cNvSpPr txBox="1"/>
+          <p:nvPr/>
+        </p:nvSpPr>
+        <p:spPr>
+          <a:xfrm>
+            <a:off x="4937760" y="1874519"/>
+            <a:ext cx="4937760" cy="457200"/>
+          </a:xfrm>
+          <a:prstGeom prst="rect">
+            <a:avLst/>
+          </a:prstGeom>
+          <a:noFill/>
+        </p:spPr>
+        <p:txBody>
+          <a:bodyPr wrap="square" anchor="t" lIns="0" rIns="0" tIns="0" bIns="0">
+            <a:spAutoFit/>
+          </a:bodyPr>
+          <a:lstStyle/>
+          <a:p>
+            <a:pPr algn="l"/>
+            <a:r>
+              <a:rPr sz="2400" b="1" i="0">
+                <a:solidFill>
+                  <a:srgbClr val="14141C"/>
+                </a:solidFill>
+                <a:latin typeface="Geist Mono"/>
+              </a:rPr>
+              <a:t>overall accuracy</a:t>
+            </a:r>
+          </a:p>
+        </p:txBody>
+      </p:sp>
+      <p:sp>
+        <p:nvSpPr>
+          <p:cNvPr id="9" name="TextBox 8"/>
+          <p:cNvSpPr txBox="1"/>
+          <p:nvPr/>
+        </p:nvSpPr>
+        <p:spPr>
+          <a:xfrm>
+            <a:off x="4937760" y="2359152"/>
+            <a:ext cx="5852160" cy="457200"/>
+          </a:xfrm>
+          <a:prstGeom prst="rect">
+            <a:avLst/>
+          </a:prstGeom>
+          <a:noFill/>
+        </p:spPr>
+        <p:txBody>
+          <a:bodyPr wrap="square" anchor="t" lIns="0" rIns="0" tIns="0" bIns="0">
+            <a:spAutoFit/>
+          </a:bodyPr>
+          <a:lstStyle/>
+          <a:p>
+            <a:pPr algn="l"/>
+            <a:r>
+              <a:rPr sz="1500" b="0" i="0">
+                <a:solidFill>
+                  <a:srgbClr val="555560"/>
+                </a:solidFill>
+                <a:latin typeface="Geist"/>
+              </a:rPr>
+              <a:t>across all seven conditions, blended into one number</a:t>
+            </a:r>
+          </a:p>
+        </p:txBody>
+      </p:sp>
+      <p:sp>
+        <p:nvSpPr>
+          <p:cNvPr id="10" name="Rectangle 9"/>
+          <p:cNvSpPr/>
+          <p:nvPr/>
+        </p:nvSpPr>
+        <p:spPr>
+          <a:xfrm>
+            <a:off x="502920" y="3246120"/>
+            <a:ext cx="2560320" cy="91440"/>
+          </a:xfrm>
+          <a:prstGeom prst="rect">
+            <a:avLst/>
+          </a:prstGeom>
+          <a:solidFill>
+            <a:srgbClr val="F0C840"/>
+          </a:solidFill>
+          <a:ln>
+            <a:noFill/>
+          </a:ln>
+          <a:effectLst/>
+        </p:spPr>
+        <p:style>
+          <a:lnRef idx="1">
+            <a:schemeClr val="accent1"/>
+          </a:lnRef>
+          <a:fillRef idx="3">
+            <a:schemeClr val="accent1"/>
+          </a:fillRef>
+          <a:effectRef idx="2">
+            <a:schemeClr val="accent1"/>
+          </a:effectRef>
+          <a:fontRef idx="minor">
+            <a:schemeClr val="lt1"/>
+          </a:fontRef>
+        </p:style>
+        <p:txBody>
+          <a:bodyPr rtlCol="0" anchor="ctr"/>
+          <a:lstStyle/>
+          <a:p>
+            <a:pPr algn="ctr"/>
+          </a:p>
+        </p:txBody>
+      </p:sp>
+      <p:sp>
+        <p:nvSpPr>
+          <p:cNvPr id="11" name="TextBox 10"/>
+          <p:cNvSpPr txBox="1"/>
+          <p:nvPr/>
+        </p:nvSpPr>
+        <p:spPr>
+          <a:xfrm>
+            <a:off x="502920" y="3520440"/>
+            <a:ext cx="8961120" cy="1463040"/>
+          </a:xfrm>
+          <a:prstGeom prst="rect">
+            <a:avLst/>
+          </a:prstGeom>
+          <a:noFill/>
+        </p:spPr>
+        <p:txBody>
+          <a:bodyPr wrap="square" anchor="t" lIns="0" rIns="0" tIns="0" bIns="0">
+            <a:spAutoFit/>
+          </a:bodyPr>
+          <a:lstStyle/>
+          <a:p>
+            <a:pPr algn="l"/>
+            <a:r>
+              <a:rPr sz="1900" b="0" i="0">
                 <a:solidFill>
                   <a:srgbClr val="14141C"/>
                 </a:solidFill>
                 <a:latin typeface="Geist"/>
               </a:rPr>
-              <a:t>Trained and tested on held-out images, the model lands at about sixty-eight percent overall accuracy. Not amazing, not embarrassing, the kind of number you would quietly accept and move on. This is exactly the moment the equity lens says stop and break it apart.</a:t>
+              <a:t>Not amazing, not embarrassing -- the kind of number you would quietly accept and move on. This is exactly the moment the equity lens says: stop, and break it apart.</a:t>
             </a:r>
           </a:p>
         </p:txBody>
@@ -6309,14 +8104,58 @@
       </p:sp>
       <p:sp>
         <p:nvSpPr>
-          <p:cNvPr id="7" name="TextBox 6"/>
+          <p:cNvPr id="7" name="Rectangle 6"/>
+          <p:cNvSpPr/>
+          <p:nvPr/>
+        </p:nvSpPr>
+        <p:spPr>
+          <a:xfrm>
+            <a:off x="484632" y="2093976"/>
+            <a:ext cx="868680" cy="82296"/>
+          </a:xfrm>
+          <a:prstGeom prst="rect">
+            <a:avLst/>
+          </a:prstGeom>
+          <a:solidFill>
+            <a:srgbClr val="8A2BE2"/>
+          </a:solidFill>
+          <a:ln>
+            <a:noFill/>
+          </a:ln>
+          <a:effectLst/>
+        </p:spPr>
+        <p:style>
+          <a:lnRef idx="1">
+            <a:schemeClr val="accent1"/>
+          </a:lnRef>
+          <a:fillRef idx="3">
+            <a:schemeClr val="accent1"/>
+          </a:fillRef>
+          <a:effectRef idx="2">
+            <a:schemeClr val="accent1"/>
+          </a:effectRef>
+          <a:fontRef idx="minor">
+            <a:schemeClr val="lt1"/>
+          </a:fontRef>
+        </p:style>
+        <p:txBody>
+          <a:bodyPr rtlCol="0" anchor="ctr"/>
+          <a:lstStyle/>
+          <a:p>
+            <a:pPr algn="ctr"/>
+          </a:p>
+        </p:txBody>
+      </p:sp>
+      <p:sp>
+        <p:nvSpPr>
+          <p:cNvPr id="8" name="TextBox 7"/>
           <p:cNvSpPr txBox="1"/>
           <p:nvPr/>
         </p:nvSpPr>
         <p:spPr>
           <a:xfrm>
-            <a:off x="548640" y="1234440"/>
-            <a:ext cx="11064240" cy="896112"/>
+            <a:off x="457200" y="2350008"/>
+            <a:ext cx="10149840" cy="1097280"/>
           </a:xfrm>
           <a:prstGeom prst="rect">
             <a:avLst/>
@@ -6331,13 +8170,48 @@
           <a:p>
             <a:pPr algn="l"/>
             <a:r>
-              <a:rPr sz="1400" b="0" i="0">
+              <a:rPr sz="3000" b="1" i="0">
+                <a:solidFill>
+                  <a:srgbClr val="14141C"/>
+                </a:solidFill>
+                <a:latin typeface="Geist Mono"/>
+              </a:rPr>
+              <a:t>Worst where care is scarcest.</a:t>
+            </a:r>
+          </a:p>
+        </p:txBody>
+      </p:sp>
+      <p:sp>
+        <p:nvSpPr>
+          <p:cNvPr id="9" name="TextBox 8"/>
+          <p:cNvSpPr txBox="1"/>
+          <p:nvPr/>
+        </p:nvSpPr>
+        <p:spPr>
+          <a:xfrm>
+            <a:off x="484632" y="3319272"/>
+            <a:ext cx="8869680" cy="1737360"/>
+          </a:xfrm>
+          <a:prstGeom prst="rect">
+            <a:avLst/>
+          </a:prstGeom>
+          <a:noFill/>
+        </p:spPr>
+        <p:txBody>
+          <a:bodyPr wrap="square" anchor="t" lIns="0" rIns="0" tIns="0" bIns="0">
+            <a:spAutoFit/>
+          </a:bodyPr>
+          <a:lstStyle/>
+          <a:p>
+            <a:pPr algn="l"/>
+            <a:r>
+              <a:rPr sz="1900" b="0" i="0">
                 <a:solidFill>
                   <a:srgbClr val="14141C"/>
                 </a:solidFill>
                 <a:latin typeface="Geist"/>
               </a:rPr>
-              <a:t>The people the pitch was meant to help most are the ones most likely missing from the data. Skin-cancer AI aimed at the three billion with little access serves people disproportionately in regions and skin types barely present in training sets. A tool that is worst where care is scarcest can widen the gap it was sold to close.</a:t>
+              <a:t>The people the pitch was meant to help most are the ones most likely missing from the data -- disproportionately in regions and skin types barely present in training sets. A tool that is worst where care is scarcest can widen the gap it was sold to close.</a:t>
             </a:r>
           </a:p>
         </p:txBody>
@@ -6564,14 +8438,58 @@
       </p:sp>
       <p:sp>
         <p:nvSpPr>
-          <p:cNvPr id="7" name="TextBox 6"/>
+          <p:cNvPr id="7" name="Rectangle 6"/>
+          <p:cNvSpPr/>
+          <p:nvPr/>
+        </p:nvSpPr>
+        <p:spPr>
+          <a:xfrm>
+            <a:off x="457200" y="1161288"/>
+            <a:ext cx="292608" cy="292608"/>
+          </a:xfrm>
+          <a:prstGeom prst="rect">
+            <a:avLst/>
+          </a:prstGeom>
+          <a:solidFill>
+            <a:srgbClr val="8A2BE2"/>
+          </a:solidFill>
+          <a:ln>
+            <a:noFill/>
+          </a:ln>
+          <a:effectLst/>
+        </p:spPr>
+        <p:style>
+          <a:lnRef idx="1">
+            <a:schemeClr val="accent1"/>
+          </a:lnRef>
+          <a:fillRef idx="3">
+            <a:schemeClr val="accent1"/>
+          </a:fillRef>
+          <a:effectRef idx="2">
+            <a:schemeClr val="accent1"/>
+          </a:effectRef>
+          <a:fontRef idx="minor">
+            <a:schemeClr val="lt1"/>
+          </a:fontRef>
+        </p:style>
+        <p:txBody>
+          <a:bodyPr rtlCol="0" anchor="ctr"/>
+          <a:lstStyle/>
+          <a:p>
+            <a:pPr algn="ctr"/>
+          </a:p>
+        </p:txBody>
+      </p:sp>
+      <p:sp>
+        <p:nvSpPr>
+          <p:cNvPr id="8" name="TextBox 7"/>
           <p:cNvSpPr txBox="1"/>
           <p:nvPr/>
         </p:nvSpPr>
         <p:spPr>
           <a:xfrm>
-            <a:off x="548640" y="1234440"/>
-            <a:ext cx="11064240" cy="694944"/>
+            <a:off x="457200" y="1152144"/>
+            <a:ext cx="292608" cy="292608"/>
           </a:xfrm>
           <a:prstGeom prst="rect">
             <a:avLst/>
@@ -6584,15 +8502,979 @@
           </a:bodyPr>
           <a:lstStyle/>
           <a:p>
+            <a:pPr algn="ctr"/>
+            <a:r>
+              <a:rPr sz="1500" b="1" i="0">
+                <a:solidFill>
+                  <a:srgbClr val="FFFFFF"/>
+                </a:solidFill>
+                <a:latin typeface="Geist Mono"/>
+              </a:rPr>
+              <a:t>1</a:t>
+            </a:r>
+          </a:p>
+        </p:txBody>
+      </p:sp>
+      <p:sp>
+        <p:nvSpPr>
+          <p:cNvPr id="9" name="TextBox 8"/>
+          <p:cNvSpPr txBox="1"/>
+          <p:nvPr/>
+        </p:nvSpPr>
+        <p:spPr>
+          <a:xfrm>
+            <a:off x="877824" y="1143000"/>
+            <a:ext cx="4928616" cy="310896"/>
+          </a:xfrm>
+          <a:prstGeom prst="rect">
+            <a:avLst/>
+          </a:prstGeom>
+          <a:noFill/>
+        </p:spPr>
+        <p:txBody>
+          <a:bodyPr wrap="square" anchor="t" lIns="0" rIns="0" tIns="0" bIns="0">
+            <a:spAutoFit/>
+          </a:bodyPr>
+          <a:lstStyle/>
+          <a:p>
             <a:pPr algn="l"/>
             <a:r>
-              <a:rPr sz="1400" b="0" i="0">
+              <a:rPr sz="1500" b="1" i="0">
                 <a:solidFill>
                   <a:srgbClr val="14141C"/>
                 </a:solidFill>
+                <a:latin typeface="Geist Mono"/>
+              </a:rPr>
+              <a:t>Fitzpatrick 1988</a:t>
+            </a:r>
+          </a:p>
+        </p:txBody>
+      </p:sp>
+      <p:sp>
+        <p:nvSpPr>
+          <p:cNvPr id="10" name="TextBox 9"/>
+          <p:cNvSpPr txBox="1"/>
+          <p:nvPr/>
+        </p:nvSpPr>
+        <p:spPr>
+          <a:xfrm>
+            <a:off x="877824" y="1472184"/>
+            <a:ext cx="4928616" cy="777240"/>
+          </a:xfrm>
+          <a:prstGeom prst="rect">
+            <a:avLst/>
+          </a:prstGeom>
+          <a:noFill/>
+        </p:spPr>
+        <p:txBody>
+          <a:bodyPr wrap="square" anchor="t" lIns="0" rIns="0" tIns="0" bIns="0">
+            <a:spAutoFit/>
+          </a:bodyPr>
+          <a:lstStyle/>
+          <a:p>
+            <a:pPr algn="l"/>
+            <a:r>
+              <a:rPr sz="1200" b="0" i="0">
+                <a:solidFill>
+                  <a:srgbClr val="555560"/>
+                </a:solidFill>
                 <a:latin typeface="Geist"/>
               </a:rPr>
-              <a:t>The equity lens on dermatology AI rests on a specific body of work, from the Fitzpatrick scale that names the groups to the studies that measured the gaps and the proxy-bias case that explains why a fair-looking number can still be unfair.</a:t>
+              <a:t>The six-point skin-type scale (I-VI) dermatology AI now uses to describe who is in a dataset.</a:t>
+            </a:r>
+          </a:p>
+        </p:txBody>
+      </p:sp>
+      <p:sp>
+        <p:nvSpPr>
+          <p:cNvPr id="11" name="Rectangle 10"/>
+          <p:cNvSpPr/>
+          <p:nvPr/>
+        </p:nvSpPr>
+        <p:spPr>
+          <a:xfrm>
+            <a:off x="457200" y="2350008"/>
+            <a:ext cx="292608" cy="292608"/>
+          </a:xfrm>
+          <a:prstGeom prst="rect">
+            <a:avLst/>
+          </a:prstGeom>
+          <a:solidFill>
+            <a:srgbClr val="8A2BE2"/>
+          </a:solidFill>
+          <a:ln>
+            <a:noFill/>
+          </a:ln>
+          <a:effectLst/>
+        </p:spPr>
+        <p:style>
+          <a:lnRef idx="1">
+            <a:schemeClr val="accent1"/>
+          </a:lnRef>
+          <a:fillRef idx="3">
+            <a:schemeClr val="accent1"/>
+          </a:fillRef>
+          <a:effectRef idx="2">
+            <a:schemeClr val="accent1"/>
+          </a:effectRef>
+          <a:fontRef idx="minor">
+            <a:schemeClr val="lt1"/>
+          </a:fontRef>
+        </p:style>
+        <p:txBody>
+          <a:bodyPr rtlCol="0" anchor="ctr"/>
+          <a:lstStyle/>
+          <a:p>
+            <a:pPr algn="ctr"/>
+          </a:p>
+        </p:txBody>
+      </p:sp>
+      <p:sp>
+        <p:nvSpPr>
+          <p:cNvPr id="12" name="TextBox 11"/>
+          <p:cNvSpPr txBox="1"/>
+          <p:nvPr/>
+        </p:nvSpPr>
+        <p:spPr>
+          <a:xfrm>
+            <a:off x="457200" y="2340864"/>
+            <a:ext cx="292608" cy="292608"/>
+          </a:xfrm>
+          <a:prstGeom prst="rect">
+            <a:avLst/>
+          </a:prstGeom>
+          <a:noFill/>
+        </p:spPr>
+        <p:txBody>
+          <a:bodyPr wrap="square" anchor="t" lIns="0" rIns="0" tIns="0" bIns="0">
+            <a:spAutoFit/>
+          </a:bodyPr>
+          <a:lstStyle/>
+          <a:p>
+            <a:pPr algn="ctr"/>
+            <a:r>
+              <a:rPr sz="1500" b="1" i="0">
+                <a:solidFill>
+                  <a:srgbClr val="FFFFFF"/>
+                </a:solidFill>
+                <a:latin typeface="Geist Mono"/>
+              </a:rPr>
+              <a:t>2</a:t>
+            </a:r>
+          </a:p>
+        </p:txBody>
+      </p:sp>
+      <p:sp>
+        <p:nvSpPr>
+          <p:cNvPr id="13" name="TextBox 12"/>
+          <p:cNvSpPr txBox="1"/>
+          <p:nvPr/>
+        </p:nvSpPr>
+        <p:spPr>
+          <a:xfrm>
+            <a:off x="877824" y="2331720"/>
+            <a:ext cx="4928616" cy="310896"/>
+          </a:xfrm>
+          <a:prstGeom prst="rect">
+            <a:avLst/>
+          </a:prstGeom>
+          <a:noFill/>
+        </p:spPr>
+        <p:txBody>
+          <a:bodyPr wrap="square" anchor="t" lIns="0" rIns="0" tIns="0" bIns="0">
+            <a:spAutoFit/>
+          </a:bodyPr>
+          <a:lstStyle/>
+          <a:p>
+            <a:pPr algn="l"/>
+            <a:r>
+              <a:rPr sz="1500" b="1" i="0">
+                <a:solidFill>
+                  <a:srgbClr val="14141C"/>
+                </a:solidFill>
+                <a:latin typeface="Geist Mono"/>
+              </a:rPr>
+              <a:t>Groh et al. 2021</a:t>
+            </a:r>
+          </a:p>
+        </p:txBody>
+      </p:sp>
+      <p:sp>
+        <p:nvSpPr>
+          <p:cNvPr id="14" name="TextBox 13"/>
+          <p:cNvSpPr txBox="1"/>
+          <p:nvPr/>
+        </p:nvSpPr>
+        <p:spPr>
+          <a:xfrm>
+            <a:off x="877824" y="2660904"/>
+            <a:ext cx="4928616" cy="777240"/>
+          </a:xfrm>
+          <a:prstGeom prst="rect">
+            <a:avLst/>
+          </a:prstGeom>
+          <a:noFill/>
+        </p:spPr>
+        <p:txBody>
+          <a:bodyPr wrap="square" anchor="t" lIns="0" rIns="0" tIns="0" bIns="0">
+            <a:spAutoFit/>
+          </a:bodyPr>
+          <a:lstStyle/>
+          <a:p>
+            <a:pPr algn="l"/>
+            <a:r>
+              <a:rPr sz="1200" b="0" i="0">
+                <a:solidFill>
+                  <a:srgbClr val="555560"/>
+                </a:solidFill>
+                <a:latin typeface="Geist"/>
+              </a:rPr>
+              <a:t>Fitzpatrick 17k: a model is most accurate on the skin types it saw most during training.</a:t>
+            </a:r>
+          </a:p>
+        </p:txBody>
+      </p:sp>
+      <p:sp>
+        <p:nvSpPr>
+          <p:cNvPr id="15" name="Rectangle 14"/>
+          <p:cNvSpPr/>
+          <p:nvPr/>
+        </p:nvSpPr>
+        <p:spPr>
+          <a:xfrm>
+            <a:off x="457200" y="3538728"/>
+            <a:ext cx="292608" cy="292608"/>
+          </a:xfrm>
+          <a:prstGeom prst="rect">
+            <a:avLst/>
+          </a:prstGeom>
+          <a:solidFill>
+            <a:srgbClr val="8A2BE2"/>
+          </a:solidFill>
+          <a:ln>
+            <a:noFill/>
+          </a:ln>
+          <a:effectLst/>
+        </p:spPr>
+        <p:style>
+          <a:lnRef idx="1">
+            <a:schemeClr val="accent1"/>
+          </a:lnRef>
+          <a:fillRef idx="3">
+            <a:schemeClr val="accent1"/>
+          </a:fillRef>
+          <a:effectRef idx="2">
+            <a:schemeClr val="accent1"/>
+          </a:effectRef>
+          <a:fontRef idx="minor">
+            <a:schemeClr val="lt1"/>
+          </a:fontRef>
+        </p:style>
+        <p:txBody>
+          <a:bodyPr rtlCol="0" anchor="ctr"/>
+          <a:lstStyle/>
+          <a:p>
+            <a:pPr algn="ctr"/>
+          </a:p>
+        </p:txBody>
+      </p:sp>
+      <p:sp>
+        <p:nvSpPr>
+          <p:cNvPr id="16" name="TextBox 15"/>
+          <p:cNvSpPr txBox="1"/>
+          <p:nvPr/>
+        </p:nvSpPr>
+        <p:spPr>
+          <a:xfrm>
+            <a:off x="457200" y="3529584"/>
+            <a:ext cx="292608" cy="292608"/>
+          </a:xfrm>
+          <a:prstGeom prst="rect">
+            <a:avLst/>
+          </a:prstGeom>
+          <a:noFill/>
+        </p:spPr>
+        <p:txBody>
+          <a:bodyPr wrap="square" anchor="t" lIns="0" rIns="0" tIns="0" bIns="0">
+            <a:spAutoFit/>
+          </a:bodyPr>
+          <a:lstStyle/>
+          <a:p>
+            <a:pPr algn="ctr"/>
+            <a:r>
+              <a:rPr sz="1500" b="1" i="0">
+                <a:solidFill>
+                  <a:srgbClr val="FFFFFF"/>
+                </a:solidFill>
+                <a:latin typeface="Geist Mono"/>
+              </a:rPr>
+              <a:t>3</a:t>
+            </a:r>
+          </a:p>
+        </p:txBody>
+      </p:sp>
+      <p:sp>
+        <p:nvSpPr>
+          <p:cNvPr id="17" name="TextBox 16"/>
+          <p:cNvSpPr txBox="1"/>
+          <p:nvPr/>
+        </p:nvSpPr>
+        <p:spPr>
+          <a:xfrm>
+            <a:off x="877824" y="3520440"/>
+            <a:ext cx="4928616" cy="310896"/>
+          </a:xfrm>
+          <a:prstGeom prst="rect">
+            <a:avLst/>
+          </a:prstGeom>
+          <a:noFill/>
+        </p:spPr>
+        <p:txBody>
+          <a:bodyPr wrap="square" anchor="t" lIns="0" rIns="0" tIns="0" bIns="0">
+            <a:spAutoFit/>
+          </a:bodyPr>
+          <a:lstStyle/>
+          <a:p>
+            <a:pPr algn="l"/>
+            <a:r>
+              <a:rPr sz="1500" b="1" i="0">
+                <a:solidFill>
+                  <a:srgbClr val="14141C"/>
+                </a:solidFill>
+                <a:latin typeface="Geist Mono"/>
+              </a:rPr>
+              <a:t>Daneshjou et al. 2022</a:t>
+            </a:r>
+          </a:p>
+        </p:txBody>
+      </p:sp>
+      <p:sp>
+        <p:nvSpPr>
+          <p:cNvPr id="18" name="TextBox 17"/>
+          <p:cNvSpPr txBox="1"/>
+          <p:nvPr/>
+        </p:nvSpPr>
+        <p:spPr>
+          <a:xfrm>
+            <a:off x="877824" y="3849624"/>
+            <a:ext cx="4928616" cy="777240"/>
+          </a:xfrm>
+          <a:prstGeom prst="rect">
+            <a:avLst/>
+          </a:prstGeom>
+          <a:noFill/>
+        </p:spPr>
+        <p:txBody>
+          <a:bodyPr wrap="square" anchor="t" lIns="0" rIns="0" tIns="0" bIns="0">
+            <a:spAutoFit/>
+          </a:bodyPr>
+          <a:lstStyle/>
+          <a:p>
+            <a:pPr algn="l"/>
+            <a:r>
+              <a:rPr sz="1200" b="0" i="0">
+                <a:solidFill>
+                  <a:srgbClr val="555560"/>
+                </a:solidFill>
+                <a:latin typeface="Geist"/>
+              </a:rPr>
+              <a:t>Diverse Dermatology Images: state-of-the-art models drop sharply on dark skin tones.</a:t>
+            </a:r>
+          </a:p>
+        </p:txBody>
+      </p:sp>
+      <p:sp>
+        <p:nvSpPr>
+          <p:cNvPr id="19" name="Rectangle 18"/>
+          <p:cNvSpPr/>
+          <p:nvPr/>
+        </p:nvSpPr>
+        <p:spPr>
+          <a:xfrm>
+            <a:off x="457200" y="4727448"/>
+            <a:ext cx="292608" cy="292608"/>
+          </a:xfrm>
+          <a:prstGeom prst="rect">
+            <a:avLst/>
+          </a:prstGeom>
+          <a:solidFill>
+            <a:srgbClr val="8A2BE2"/>
+          </a:solidFill>
+          <a:ln>
+            <a:noFill/>
+          </a:ln>
+          <a:effectLst/>
+        </p:spPr>
+        <p:style>
+          <a:lnRef idx="1">
+            <a:schemeClr val="accent1"/>
+          </a:lnRef>
+          <a:fillRef idx="3">
+            <a:schemeClr val="accent1"/>
+          </a:fillRef>
+          <a:effectRef idx="2">
+            <a:schemeClr val="accent1"/>
+          </a:effectRef>
+          <a:fontRef idx="minor">
+            <a:schemeClr val="lt1"/>
+          </a:fontRef>
+        </p:style>
+        <p:txBody>
+          <a:bodyPr rtlCol="0" anchor="ctr"/>
+          <a:lstStyle/>
+          <a:p>
+            <a:pPr algn="ctr"/>
+          </a:p>
+        </p:txBody>
+      </p:sp>
+      <p:sp>
+        <p:nvSpPr>
+          <p:cNvPr id="20" name="TextBox 19"/>
+          <p:cNvSpPr txBox="1"/>
+          <p:nvPr/>
+        </p:nvSpPr>
+        <p:spPr>
+          <a:xfrm>
+            <a:off x="457200" y="4718304"/>
+            <a:ext cx="292608" cy="292608"/>
+          </a:xfrm>
+          <a:prstGeom prst="rect">
+            <a:avLst/>
+          </a:prstGeom>
+          <a:noFill/>
+        </p:spPr>
+        <p:txBody>
+          <a:bodyPr wrap="square" anchor="t" lIns="0" rIns="0" tIns="0" bIns="0">
+            <a:spAutoFit/>
+          </a:bodyPr>
+          <a:lstStyle/>
+          <a:p>
+            <a:pPr algn="ctr"/>
+            <a:r>
+              <a:rPr sz="1500" b="1" i="0">
+                <a:solidFill>
+                  <a:srgbClr val="FFFFFF"/>
+                </a:solidFill>
+                <a:latin typeface="Geist Mono"/>
+              </a:rPr>
+              <a:t>4</a:t>
+            </a:r>
+          </a:p>
+        </p:txBody>
+      </p:sp>
+      <p:sp>
+        <p:nvSpPr>
+          <p:cNvPr id="21" name="TextBox 20"/>
+          <p:cNvSpPr txBox="1"/>
+          <p:nvPr/>
+        </p:nvSpPr>
+        <p:spPr>
+          <a:xfrm>
+            <a:off x="877824" y="4709160"/>
+            <a:ext cx="4928616" cy="310896"/>
+          </a:xfrm>
+          <a:prstGeom prst="rect">
+            <a:avLst/>
+          </a:prstGeom>
+          <a:noFill/>
+        </p:spPr>
+        <p:txBody>
+          <a:bodyPr wrap="square" anchor="t" lIns="0" rIns="0" tIns="0" bIns="0">
+            <a:spAutoFit/>
+          </a:bodyPr>
+          <a:lstStyle/>
+          <a:p>
+            <a:pPr algn="l"/>
+            <a:r>
+              <a:rPr sz="1500" b="1" i="0">
+                <a:solidFill>
+                  <a:srgbClr val="14141C"/>
+                </a:solidFill>
+                <a:latin typeface="Geist Mono"/>
+              </a:rPr>
+              <a:t>Obermeyer et al. 2019</a:t>
+            </a:r>
+          </a:p>
+        </p:txBody>
+      </p:sp>
+      <p:sp>
+        <p:nvSpPr>
+          <p:cNvPr id="22" name="TextBox 21"/>
+          <p:cNvSpPr txBox="1"/>
+          <p:nvPr/>
+        </p:nvSpPr>
+        <p:spPr>
+          <a:xfrm>
+            <a:off x="877824" y="5038344"/>
+            <a:ext cx="4928616" cy="777240"/>
+          </a:xfrm>
+          <a:prstGeom prst="rect">
+            <a:avLst/>
+          </a:prstGeom>
+          <a:noFill/>
+        </p:spPr>
+        <p:txBody>
+          <a:bodyPr wrap="square" anchor="t" lIns="0" rIns="0" tIns="0" bIns="0">
+            <a:spAutoFit/>
+          </a:bodyPr>
+          <a:lstStyle/>
+          <a:p>
+            <a:pPr algn="l"/>
+            <a:r>
+              <a:rPr sz="1200" b="0" i="0">
+                <a:solidFill>
+                  <a:srgbClr val="555560"/>
+                </a:solidFill>
+                <a:latin typeface="Geist"/>
+              </a:rPr>
+              <a:t>A health algorithm underserved Black patients by predicting cost instead of illness.</a:t>
+            </a:r>
+          </a:p>
+        </p:txBody>
+      </p:sp>
+      <p:sp>
+        <p:nvSpPr>
+          <p:cNvPr id="23" name="Rectangle 22"/>
+          <p:cNvSpPr/>
+          <p:nvPr/>
+        </p:nvSpPr>
+        <p:spPr>
+          <a:xfrm>
+            <a:off x="6355080" y="1161288"/>
+            <a:ext cx="292608" cy="292608"/>
+          </a:xfrm>
+          <a:prstGeom prst="rect">
+            <a:avLst/>
+          </a:prstGeom>
+          <a:solidFill>
+            <a:srgbClr val="8A2BE2"/>
+          </a:solidFill>
+          <a:ln>
+            <a:noFill/>
+          </a:ln>
+          <a:effectLst/>
+        </p:spPr>
+        <p:style>
+          <a:lnRef idx="1">
+            <a:schemeClr val="accent1"/>
+          </a:lnRef>
+          <a:fillRef idx="3">
+            <a:schemeClr val="accent1"/>
+          </a:fillRef>
+          <a:effectRef idx="2">
+            <a:schemeClr val="accent1"/>
+          </a:effectRef>
+          <a:fontRef idx="minor">
+            <a:schemeClr val="lt1"/>
+          </a:fontRef>
+        </p:style>
+        <p:txBody>
+          <a:bodyPr rtlCol="0" anchor="ctr"/>
+          <a:lstStyle/>
+          <a:p>
+            <a:pPr algn="ctr"/>
+          </a:p>
+        </p:txBody>
+      </p:sp>
+      <p:sp>
+        <p:nvSpPr>
+          <p:cNvPr id="24" name="TextBox 23"/>
+          <p:cNvSpPr txBox="1"/>
+          <p:nvPr/>
+        </p:nvSpPr>
+        <p:spPr>
+          <a:xfrm>
+            <a:off x="6355080" y="1152144"/>
+            <a:ext cx="292608" cy="292608"/>
+          </a:xfrm>
+          <a:prstGeom prst="rect">
+            <a:avLst/>
+          </a:prstGeom>
+          <a:noFill/>
+        </p:spPr>
+        <p:txBody>
+          <a:bodyPr wrap="square" anchor="t" lIns="0" rIns="0" tIns="0" bIns="0">
+            <a:spAutoFit/>
+          </a:bodyPr>
+          <a:lstStyle/>
+          <a:p>
+            <a:pPr algn="ctr"/>
+            <a:r>
+              <a:rPr sz="1500" b="1" i="0">
+                <a:solidFill>
+                  <a:srgbClr val="FFFFFF"/>
+                </a:solidFill>
+                <a:latin typeface="Geist Mono"/>
+              </a:rPr>
+              <a:t>5</a:t>
+            </a:r>
+          </a:p>
+        </p:txBody>
+      </p:sp>
+      <p:sp>
+        <p:nvSpPr>
+          <p:cNvPr id="25" name="TextBox 24"/>
+          <p:cNvSpPr txBox="1"/>
+          <p:nvPr/>
+        </p:nvSpPr>
+        <p:spPr>
+          <a:xfrm>
+            <a:off x="6775704" y="1143000"/>
+            <a:ext cx="4928616" cy="310896"/>
+          </a:xfrm>
+          <a:prstGeom prst="rect">
+            <a:avLst/>
+          </a:prstGeom>
+          <a:noFill/>
+        </p:spPr>
+        <p:txBody>
+          <a:bodyPr wrap="square" anchor="t" lIns="0" rIns="0" tIns="0" bIns="0">
+            <a:spAutoFit/>
+          </a:bodyPr>
+          <a:lstStyle/>
+          <a:p>
+            <a:pPr algn="l"/>
+            <a:r>
+              <a:rPr sz="1500" b="1" i="0">
+                <a:solidFill>
+                  <a:srgbClr val="14141C"/>
+                </a:solidFill>
+                <a:latin typeface="Geist Mono"/>
+              </a:rPr>
+              <a:t>Wen et al. 2022</a:t>
+            </a:r>
+          </a:p>
+        </p:txBody>
+      </p:sp>
+      <p:sp>
+        <p:nvSpPr>
+          <p:cNvPr id="26" name="TextBox 25"/>
+          <p:cNvSpPr txBox="1"/>
+          <p:nvPr/>
+        </p:nvSpPr>
+        <p:spPr>
+          <a:xfrm>
+            <a:off x="6775704" y="1472184"/>
+            <a:ext cx="4928616" cy="777240"/>
+          </a:xfrm>
+          <a:prstGeom prst="rect">
+            <a:avLst/>
+          </a:prstGeom>
+          <a:noFill/>
+        </p:spPr>
+        <p:txBody>
+          <a:bodyPr wrap="square" anchor="t" lIns="0" rIns="0" tIns="0" bIns="0">
+            <a:spAutoFit/>
+          </a:bodyPr>
+          <a:lstStyle/>
+          <a:p>
+            <a:pPr algn="l"/>
+            <a:r>
+              <a:rPr sz="1200" b="0" i="0">
+                <a:solidFill>
+                  <a:srgbClr val="555560"/>
+                </a:solidFill>
+                <a:latin typeface="Geist"/>
+              </a:rPr>
+              <a:t>Review of 21 public skin datasets (106,950 images): almost all are light-skinned.</a:t>
+            </a:r>
+          </a:p>
+        </p:txBody>
+      </p:sp>
+      <p:sp>
+        <p:nvSpPr>
+          <p:cNvPr id="27" name="Rectangle 26"/>
+          <p:cNvSpPr/>
+          <p:nvPr/>
+        </p:nvSpPr>
+        <p:spPr>
+          <a:xfrm>
+            <a:off x="6355080" y="2350008"/>
+            <a:ext cx="292608" cy="292608"/>
+          </a:xfrm>
+          <a:prstGeom prst="rect">
+            <a:avLst/>
+          </a:prstGeom>
+          <a:solidFill>
+            <a:srgbClr val="8A2BE2"/>
+          </a:solidFill>
+          <a:ln>
+            <a:noFill/>
+          </a:ln>
+          <a:effectLst/>
+        </p:spPr>
+        <p:style>
+          <a:lnRef idx="1">
+            <a:schemeClr val="accent1"/>
+          </a:lnRef>
+          <a:fillRef idx="3">
+            <a:schemeClr val="accent1"/>
+          </a:fillRef>
+          <a:effectRef idx="2">
+            <a:schemeClr val="accent1"/>
+          </a:effectRef>
+          <a:fontRef idx="minor">
+            <a:schemeClr val="lt1"/>
+          </a:fontRef>
+        </p:style>
+        <p:txBody>
+          <a:bodyPr rtlCol="0" anchor="ctr"/>
+          <a:lstStyle/>
+          <a:p>
+            <a:pPr algn="ctr"/>
+          </a:p>
+        </p:txBody>
+      </p:sp>
+      <p:sp>
+        <p:nvSpPr>
+          <p:cNvPr id="28" name="TextBox 27"/>
+          <p:cNvSpPr txBox="1"/>
+          <p:nvPr/>
+        </p:nvSpPr>
+        <p:spPr>
+          <a:xfrm>
+            <a:off x="6355080" y="2340864"/>
+            <a:ext cx="292608" cy="292608"/>
+          </a:xfrm>
+          <a:prstGeom prst="rect">
+            <a:avLst/>
+          </a:prstGeom>
+          <a:noFill/>
+        </p:spPr>
+        <p:txBody>
+          <a:bodyPr wrap="square" anchor="t" lIns="0" rIns="0" tIns="0" bIns="0">
+            <a:spAutoFit/>
+          </a:bodyPr>
+          <a:lstStyle/>
+          <a:p>
+            <a:pPr algn="ctr"/>
+            <a:r>
+              <a:rPr sz="1500" b="1" i="0">
+                <a:solidFill>
+                  <a:srgbClr val="FFFFFF"/>
+                </a:solidFill>
+                <a:latin typeface="Geist Mono"/>
+              </a:rPr>
+              <a:t>6</a:t>
+            </a:r>
+          </a:p>
+        </p:txBody>
+      </p:sp>
+      <p:sp>
+        <p:nvSpPr>
+          <p:cNvPr id="29" name="TextBox 28"/>
+          <p:cNvSpPr txBox="1"/>
+          <p:nvPr/>
+        </p:nvSpPr>
+        <p:spPr>
+          <a:xfrm>
+            <a:off x="6775704" y="2331720"/>
+            <a:ext cx="4928616" cy="310896"/>
+          </a:xfrm>
+          <a:prstGeom prst="rect">
+            <a:avLst/>
+          </a:prstGeom>
+          <a:noFill/>
+        </p:spPr>
+        <p:txBody>
+          <a:bodyPr wrap="square" anchor="t" lIns="0" rIns="0" tIns="0" bIns="0">
+            <a:spAutoFit/>
+          </a:bodyPr>
+          <a:lstStyle/>
+          <a:p>
+            <a:pPr algn="l"/>
+            <a:r>
+              <a:rPr sz="1500" b="1" i="0">
+                <a:solidFill>
+                  <a:srgbClr val="14141C"/>
+                </a:solidFill>
+                <a:latin typeface="Geist Mono"/>
+              </a:rPr>
+              <a:t>Adamson &amp; Smith 2018</a:t>
+            </a:r>
+          </a:p>
+        </p:txBody>
+      </p:sp>
+      <p:sp>
+        <p:nvSpPr>
+          <p:cNvPr id="30" name="TextBox 29"/>
+          <p:cNvSpPr txBox="1"/>
+          <p:nvPr/>
+        </p:nvSpPr>
+        <p:spPr>
+          <a:xfrm>
+            <a:off x="6775704" y="2660904"/>
+            <a:ext cx="4928616" cy="777240"/>
+          </a:xfrm>
+          <a:prstGeom prst="rect">
+            <a:avLst/>
+          </a:prstGeom>
+          <a:noFill/>
+        </p:spPr>
+        <p:txBody>
+          <a:bodyPr wrap="square" anchor="t" lIns="0" rIns="0" tIns="0" bIns="0">
+            <a:spAutoFit/>
+          </a:bodyPr>
+          <a:lstStyle/>
+          <a:p>
+            <a:pPr algn="l"/>
+            <a:r>
+              <a:rPr sz="1200" b="0" i="0">
+                <a:solidFill>
+                  <a:srgbClr val="555560"/>
+                </a:solidFill>
+                <a:latin typeface="Geist"/>
+              </a:rPr>
+              <a:t>AI trained on fair-skinned archives can widen, not close, dermatology care gaps.</a:t>
+            </a:r>
+          </a:p>
+        </p:txBody>
+      </p:sp>
+      <p:sp>
+        <p:nvSpPr>
+          <p:cNvPr id="31" name="Rectangle 30"/>
+          <p:cNvSpPr/>
+          <p:nvPr/>
+        </p:nvSpPr>
+        <p:spPr>
+          <a:xfrm>
+            <a:off x="6355080" y="3538728"/>
+            <a:ext cx="292608" cy="292608"/>
+          </a:xfrm>
+          <a:prstGeom prst="rect">
+            <a:avLst/>
+          </a:prstGeom>
+          <a:solidFill>
+            <a:srgbClr val="8A2BE2"/>
+          </a:solidFill>
+          <a:ln>
+            <a:noFill/>
+          </a:ln>
+          <a:effectLst/>
+        </p:spPr>
+        <p:style>
+          <a:lnRef idx="1">
+            <a:schemeClr val="accent1"/>
+          </a:lnRef>
+          <a:fillRef idx="3">
+            <a:schemeClr val="accent1"/>
+          </a:fillRef>
+          <a:effectRef idx="2">
+            <a:schemeClr val="accent1"/>
+          </a:effectRef>
+          <a:fontRef idx="minor">
+            <a:schemeClr val="lt1"/>
+          </a:fontRef>
+        </p:style>
+        <p:txBody>
+          <a:bodyPr rtlCol="0" anchor="ctr"/>
+          <a:lstStyle/>
+          <a:p>
+            <a:pPr algn="ctr"/>
+          </a:p>
+        </p:txBody>
+      </p:sp>
+      <p:sp>
+        <p:nvSpPr>
+          <p:cNvPr id="32" name="TextBox 31"/>
+          <p:cNvSpPr txBox="1"/>
+          <p:nvPr/>
+        </p:nvSpPr>
+        <p:spPr>
+          <a:xfrm>
+            <a:off x="6355080" y="3529584"/>
+            <a:ext cx="292608" cy="292608"/>
+          </a:xfrm>
+          <a:prstGeom prst="rect">
+            <a:avLst/>
+          </a:prstGeom>
+          <a:noFill/>
+        </p:spPr>
+        <p:txBody>
+          <a:bodyPr wrap="square" anchor="t" lIns="0" rIns="0" tIns="0" bIns="0">
+            <a:spAutoFit/>
+          </a:bodyPr>
+          <a:lstStyle/>
+          <a:p>
+            <a:pPr algn="ctr"/>
+            <a:r>
+              <a:rPr sz="1500" b="1" i="0">
+                <a:solidFill>
+                  <a:srgbClr val="FFFFFF"/>
+                </a:solidFill>
+                <a:latin typeface="Geist Mono"/>
+              </a:rPr>
+              <a:t>7</a:t>
+            </a:r>
+          </a:p>
+        </p:txBody>
+      </p:sp>
+      <p:sp>
+        <p:nvSpPr>
+          <p:cNvPr id="33" name="TextBox 32"/>
+          <p:cNvSpPr txBox="1"/>
+          <p:nvPr/>
+        </p:nvSpPr>
+        <p:spPr>
+          <a:xfrm>
+            <a:off x="6775704" y="3520440"/>
+            <a:ext cx="4928616" cy="310896"/>
+          </a:xfrm>
+          <a:prstGeom prst="rect">
+            <a:avLst/>
+          </a:prstGeom>
+          <a:noFill/>
+        </p:spPr>
+        <p:txBody>
+          <a:bodyPr wrap="square" anchor="t" lIns="0" rIns="0" tIns="0" bIns="0">
+            <a:spAutoFit/>
+          </a:bodyPr>
+          <a:lstStyle/>
+          <a:p>
+            <a:pPr algn="l"/>
+            <a:r>
+              <a:rPr sz="1500" b="1" i="0">
+                <a:solidFill>
+                  <a:srgbClr val="14141C"/>
+                </a:solidFill>
+                <a:latin typeface="Geist Mono"/>
+              </a:rPr>
+              <a:t>Buster et al. 2012</a:t>
+            </a:r>
+          </a:p>
+        </p:txBody>
+      </p:sp>
+      <p:sp>
+        <p:nvSpPr>
+          <p:cNvPr id="34" name="TextBox 33"/>
+          <p:cNvSpPr txBox="1"/>
+          <p:nvPr/>
+        </p:nvSpPr>
+        <p:spPr>
+          <a:xfrm>
+            <a:off x="6775704" y="3849624"/>
+            <a:ext cx="4928616" cy="777240"/>
+          </a:xfrm>
+          <a:prstGeom prst="rect">
+            <a:avLst/>
+          </a:prstGeom>
+          <a:noFill/>
+        </p:spPr>
+        <p:txBody>
+          <a:bodyPr wrap="square" anchor="t" lIns="0" rIns="0" tIns="0" bIns="0">
+            <a:spAutoFit/>
+          </a:bodyPr>
+          <a:lstStyle/>
+          <a:p>
+            <a:pPr algn="l"/>
+            <a:r>
+              <a:rPr sz="1200" b="0" i="0">
+                <a:solidFill>
+                  <a:srgbClr val="555560"/>
+                </a:solidFill>
+                <a:latin typeface="Geist"/>
+              </a:rPr>
+              <a:t>Skin-disease outcomes are worse for underserved, low-access, minority patients.</a:t>
             </a:r>
           </a:p>
         </p:txBody>
@@ -7647,14 +10529,58 @@
       </p:sp>
       <p:sp>
         <p:nvSpPr>
-          <p:cNvPr id="7" name="TextBox 6"/>
+          <p:cNvPr id="7" name="Rectangle 6"/>
+          <p:cNvSpPr/>
+          <p:nvPr/>
+        </p:nvSpPr>
+        <p:spPr>
+          <a:xfrm>
+            <a:off x="484632" y="2093976"/>
+            <a:ext cx="868680" cy="82296"/>
+          </a:xfrm>
+          <a:prstGeom prst="rect">
+            <a:avLst/>
+          </a:prstGeom>
+          <a:solidFill>
+            <a:srgbClr val="40E0D0"/>
+          </a:solidFill>
+          <a:ln>
+            <a:noFill/>
+          </a:ln>
+          <a:effectLst/>
+        </p:spPr>
+        <p:style>
+          <a:lnRef idx="1">
+            <a:schemeClr val="accent1"/>
+          </a:lnRef>
+          <a:fillRef idx="3">
+            <a:schemeClr val="accent1"/>
+          </a:fillRef>
+          <a:effectRef idx="2">
+            <a:schemeClr val="accent1"/>
+          </a:effectRef>
+          <a:fontRef idx="minor">
+            <a:schemeClr val="lt1"/>
+          </a:fontRef>
+        </p:style>
+        <p:txBody>
+          <a:bodyPr rtlCol="0" anchor="ctr"/>
+          <a:lstStyle/>
+          <a:p>
+            <a:pPr algn="ctr"/>
+          </a:p>
+        </p:txBody>
+      </p:sp>
+      <p:sp>
+        <p:nvSpPr>
+          <p:cNvPr id="8" name="TextBox 7"/>
           <p:cNvSpPr txBox="1"/>
           <p:nvPr/>
         </p:nvSpPr>
         <p:spPr>
           <a:xfrm>
-            <a:off x="548640" y="1234440"/>
-            <a:ext cx="11064240" cy="896112"/>
+            <a:off x="457200" y="2350008"/>
+            <a:ext cx="10149840" cy="1097280"/>
           </a:xfrm>
           <a:prstGeom prst="rect">
             <a:avLst/>
@@ -7669,13 +10595,48 @@
           <a:p>
             <a:pPr algn="l"/>
             <a:r>
-              <a:rPr sz="1400" b="0" i="0">
+              <a:rPr sz="3000" b="1" i="0">
+                <a:solidFill>
+                  <a:srgbClr val="14141C"/>
+                </a:solidFill>
+                <a:latin typeface="Geist Mono"/>
+              </a:rPr>
+              <a:t>A model only learns what it is shown.</a:t>
+            </a:r>
+          </a:p>
+        </p:txBody>
+      </p:sp>
+      <p:sp>
+        <p:nvSpPr>
+          <p:cNvPr id="9" name="TextBox 8"/>
+          <p:cNvSpPr txBox="1"/>
+          <p:nvPr/>
+        </p:nvSpPr>
+        <p:spPr>
+          <a:xfrm>
+            <a:off x="484632" y="3319272"/>
+            <a:ext cx="8869680" cy="1737360"/>
+          </a:xfrm>
+          <a:prstGeom prst="rect">
+            <a:avLst/>
+          </a:prstGeom>
+          <a:noFill/>
+        </p:spPr>
+        <p:txBody>
+          <a:bodyPr wrap="square" anchor="t" lIns="0" rIns="0" tIns="0" bIns="0">
+            <a:spAutoFit/>
+          </a:bodyPr>
+          <a:lstStyle/>
+          <a:p>
+            <a:pPr algn="l"/>
+            <a:r>
+              <a:rPr sz="1900" b="0" i="0">
                 <a:solidFill>
                   <a:srgbClr val="14141C"/>
                 </a:solidFill>
                 <a:latin typeface="Geist"/>
               </a:rPr>
-              <a:t>Skin-cancer AI is pitched as a way to reach the roughly three billion people with little access to a dermatologist. That promise is real, and so is the catch: a model only learns what it is shown, and the images these models learn from are badly skewed toward light skin.</a:t>
+              <a:t>Skin-cancer AI is pitched as a way to reach the roughly three billion people with little access to a dermatologist. That promise is real, and so is the catch: the images these models learn from are badly skewed toward light skin.</a:t>
             </a:r>
           </a:p>
         </p:txBody>
@@ -9582,14 +12543,58 @@
       </p:sp>
       <p:sp>
         <p:nvSpPr>
-          <p:cNvPr id="7" name="TextBox 6"/>
+          <p:cNvPr id="7" name="Rectangle 6"/>
+          <p:cNvSpPr/>
+          <p:nvPr/>
+        </p:nvSpPr>
+        <p:spPr>
+          <a:xfrm>
+            <a:off x="484632" y="2093976"/>
+            <a:ext cx="868680" cy="82296"/>
+          </a:xfrm>
+          <a:prstGeom prst="rect">
+            <a:avLst/>
+          </a:prstGeom>
+          <a:solidFill>
+            <a:srgbClr val="FF1493"/>
+          </a:solidFill>
+          <a:ln>
+            <a:noFill/>
+          </a:ln>
+          <a:effectLst/>
+        </p:spPr>
+        <p:style>
+          <a:lnRef idx="1">
+            <a:schemeClr val="accent1"/>
+          </a:lnRef>
+          <a:fillRef idx="3">
+            <a:schemeClr val="accent1"/>
+          </a:fillRef>
+          <a:effectRef idx="2">
+            <a:schemeClr val="accent1"/>
+          </a:effectRef>
+          <a:fontRef idx="minor">
+            <a:schemeClr val="lt1"/>
+          </a:fontRef>
+        </p:style>
+        <p:txBody>
+          <a:bodyPr rtlCol="0" anchor="ctr"/>
+          <a:lstStyle/>
+          <a:p>
+            <a:pPr algn="ctr"/>
+          </a:p>
+        </p:txBody>
+      </p:sp>
+      <p:sp>
+        <p:nvSpPr>
+          <p:cNvPr id="8" name="TextBox 7"/>
           <p:cNvSpPr txBox="1"/>
           <p:nvPr/>
         </p:nvSpPr>
         <p:spPr>
           <a:xfrm>
-            <a:off x="548640" y="1234440"/>
-            <a:ext cx="11064240" cy="694944"/>
+            <a:off x="457200" y="2350008"/>
+            <a:ext cx="10149840" cy="1097280"/>
           </a:xfrm>
           <a:prstGeom prst="rect">
             <a:avLst/>
@@ -9604,13 +12609,48 @@
           <a:p>
             <a:pPr algn="l"/>
             <a:r>
-              <a:rPr sz="1400" b="0" i="0">
+              <a:rPr sz="3000" b="1" i="0">
+                <a:solidFill>
+                  <a:srgbClr val="14141C"/>
+                </a:solidFill>
+                <a:latin typeface="Geist Mono"/>
+              </a:rPr>
+              <a:t>Change the question, not the model.</a:t>
+            </a:r>
+          </a:p>
+        </p:txBody>
+      </p:sp>
+      <p:sp>
+        <p:nvSpPr>
+          <p:cNvPr id="9" name="TextBox 8"/>
+          <p:cNvSpPr txBox="1"/>
+          <p:nvPr/>
+        </p:nvSpPr>
+        <p:spPr>
+          <a:xfrm>
+            <a:off x="484632" y="3319272"/>
+            <a:ext cx="8869680" cy="1737360"/>
+          </a:xfrm>
+          <a:prstGeom prst="rect">
+            <a:avLst/>
+          </a:prstGeom>
+          <a:noFill/>
+        </p:spPr>
+        <p:txBody>
+          <a:bodyPr wrap="square" anchor="t" lIns="0" rIns="0" tIns="0" bIns="0">
+            <a:spAutoFit/>
+          </a:bodyPr>
+          <a:lstStyle/>
+          <a:p>
+            <a:pPr algn="l"/>
+            <a:r>
+              <a:rPr sz="1900" b="0" i="0">
                 <a:solidFill>
                   <a:srgbClr val="14141C"/>
                 </a:solidFill>
                 <a:latin typeface="Geist"/>
               </a:rPr>
-              <a:t>We use the exact same DermaMNIST skin-lesion model as the screening group: a ResNet18 pretrained on ordinary photos, with a fresh head, sorting images into seven skin conditions. We change nothing about the model. We change the question we ask of it.</a:t>
+              <a:t>We reuse the screening group's exact DermaMNIST model -- a ResNet18 pretrained on ordinary photos, with a fresh head, sorting images into seven skin conditions. Same tool, harder question: not how good is it, but good for whom?</a:t>
             </a:r>
           </a:p>
         </p:txBody>
@@ -9837,14 +12877,58 @@
       </p:sp>
       <p:sp>
         <p:nvSpPr>
-          <p:cNvPr id="7" name="TextBox 6"/>
+          <p:cNvPr id="7" name="Rectangle 6"/>
+          <p:cNvSpPr/>
+          <p:nvPr/>
+        </p:nvSpPr>
+        <p:spPr>
+          <a:xfrm>
+            <a:off x="484632" y="2093976"/>
+            <a:ext cx="868680" cy="82296"/>
+          </a:xfrm>
+          <a:prstGeom prst="rect">
+            <a:avLst/>
+          </a:prstGeom>
+          <a:solidFill>
+            <a:srgbClr val="FF1493"/>
+          </a:solidFill>
+          <a:ln>
+            <a:noFill/>
+          </a:ln>
+          <a:effectLst/>
+        </p:spPr>
+        <p:style>
+          <a:lnRef idx="1">
+            <a:schemeClr val="accent1"/>
+          </a:lnRef>
+          <a:fillRef idx="3">
+            <a:schemeClr val="accent1"/>
+          </a:fillRef>
+          <a:effectRef idx="2">
+            <a:schemeClr val="accent1"/>
+          </a:effectRef>
+          <a:fontRef idx="minor">
+            <a:schemeClr val="lt1"/>
+          </a:fontRef>
+        </p:style>
+        <p:txBody>
+          <a:bodyPr rtlCol="0" anchor="ctr"/>
+          <a:lstStyle/>
+          <a:p>
+            <a:pPr algn="ctr"/>
+          </a:p>
+        </p:txBody>
+      </p:sp>
+      <p:sp>
+        <p:nvSpPr>
+          <p:cNvPr id="8" name="TextBox 7"/>
           <p:cNvSpPr txBox="1"/>
           <p:nvPr/>
         </p:nvSpPr>
         <p:spPr>
           <a:xfrm>
-            <a:off x="548640" y="1234440"/>
-            <a:ext cx="11064240" cy="694944"/>
+            <a:off x="457200" y="2350008"/>
+            <a:ext cx="10149840" cy="1097280"/>
           </a:xfrm>
           <a:prstGeom prst="rect">
             <a:avLst/>
@@ -9859,13 +12943,48 @@
           <a:p>
             <a:pPr algn="l"/>
             <a:r>
-              <a:rPr sz="1400" b="0" i="0">
+              <a:rPr sz="3000" b="1" i="0">
+                <a:solidFill>
+                  <a:srgbClr val="14141C"/>
+                </a:solidFill>
+                <a:latin typeface="Geist Mono"/>
+              </a:rPr>
+              <a:t>Good for whom?</a:t>
+            </a:r>
+          </a:p>
+        </p:txBody>
+      </p:sp>
+      <p:sp>
+        <p:nvSpPr>
+          <p:cNvPr id="9" name="TextBox 8"/>
+          <p:cNvSpPr txBox="1"/>
+          <p:nvPr/>
+        </p:nvSpPr>
+        <p:spPr>
+          <a:xfrm>
+            <a:off x="484632" y="3319272"/>
+            <a:ext cx="8869680" cy="1737360"/>
+          </a:xfrm>
+          <a:prstGeom prst="rect">
+            <a:avLst/>
+          </a:prstGeom>
+          <a:noFill/>
+        </p:spPr>
+        <p:txBody>
+          <a:bodyPr wrap="square" anchor="t" lIns="0" rIns="0" tIns="0" bIns="0">
+            <a:spAutoFit/>
+          </a:bodyPr>
+          <a:lstStyle/>
+          <a:p>
+            <a:pPr algn="l"/>
+            <a:r>
+              <a:rPr sz="1900" b="0" i="0">
                 <a:solidFill>
                   <a:srgbClr val="14141C"/>
                 </a:solidFill>
                 <a:latin typeface="Geist"/>
               </a:rPr>
-              <a:t>The screening group asks how good the model is. We ask a harder question: good for whom? A single accuracy number is a blend, and a blend can hide that one group is being carried by another. So we refuse to trust the average and split the score apart by condition.</a:t>
+              <a:t>A single accuracy number is a blend, and a blend can hide that one group is being carried by another. The screening group asks how good the model is; we refuse to trust the average and split the score apart by condition.</a:t>
             </a:r>
           </a:p>
         </p:txBody>
@@ -10196,4 +13315,324 @@
   </a:objectDefaults>
   <a:extraClrSchemeLst/>
 </a:theme>
+</file>
+
+<file path=ppt/theme/theme2.xml><?xml version="1.0" encoding="utf-8"?>
+<a:theme xmlns:a="http://schemas.openxmlformats.org/drawingml/2006/main" name="Office Theme">
+  <a:themeElements>
+    <a:clrScheme name="Office">
+      <a:dk1>
+        <a:sysClr val="windowText" lastClr="000000"/>
+      </a:dk1>
+      <a:lt1>
+        <a:sysClr val="window" lastClr="FFFFFF"/>
+      </a:lt1>
+      <a:dk2>
+        <a:srgbClr val="1F497D"/>
+      </a:dk2>
+      <a:lt2>
+        <a:srgbClr val="EEECE1"/>
+      </a:lt2>
+      <a:accent1>
+        <a:srgbClr val="4F81BD"/>
+      </a:accent1>
+      <a:accent2>
+        <a:srgbClr val="C0504D"/>
+      </a:accent2>
+      <a:accent3>
+        <a:srgbClr val="9BBB59"/>
+      </a:accent3>
+      <a:accent4>
+        <a:srgbClr val="8064A2"/>
+      </a:accent4>
+      <a:accent5>
+        <a:srgbClr val="4BACC6"/>
+      </a:accent5>
+      <a:accent6>
+        <a:srgbClr val="F79646"/>
+      </a:accent6>
+      <a:hlink>
+        <a:srgbClr val="0000FF"/>
+      </a:hlink>
+      <a:folHlink>
+        <a:srgbClr val="800080"/>
+      </a:folHlink>
+    </a:clrScheme>
+    <a:fontScheme name="Office">
+      <a:majorFont>
+        <a:latin typeface="Calibri"/>
+        <a:ea typeface=""/>
+        <a:cs typeface=""/>
+        <a:font script="Jpan" typeface="ＭＳ Ｐゴシック"/>
+        <a:font script="Hang" typeface="맑은 고딕"/>
+        <a:font script="Hans" typeface="宋体"/>
+        <a:font script="Hant" typeface="新細明體"/>
+        <a:font script="Arab" typeface="Times New Roman"/>
+        <a:font script="Hebr" typeface="Times New Roman"/>
+        <a:font script="Thai" typeface="Angsana New"/>
+        <a:font script="Ethi" typeface="Nyala"/>
+        <a:font script="Beng" typeface="Vrinda"/>
+        <a:font script="Gujr" typeface="Shruti"/>
+        <a:font script="Khmr" typeface="MoolBoran"/>
+        <a:font script="Knda" typeface="Tunga"/>
+        <a:font script="Guru" typeface="Raavi"/>
+        <a:font script="Cans" typeface="Euphemia"/>
+        <a:font script="Cher" typeface="Plantagenet Cherokee"/>
+        <a:font script="Yiii" typeface="Microsoft Yi Baiti"/>
+        <a:font script="Tibt" typeface="Microsoft Himalaya"/>
+        <a:font script="Thaa" typeface="MV Boli"/>
+        <a:font script="Deva" typeface="Mangal"/>
+        <a:font script="Telu" typeface="Gautami"/>
+        <a:font script="Taml" typeface="Latha"/>
+        <a:font script="Syrc" typeface="Estrangelo Edessa"/>
+        <a:font script="Orya" typeface="Kalinga"/>
+        <a:font script="Mlym" typeface="Kartika"/>
+        <a:font script="Laoo" typeface="DokChampa"/>
+        <a:font script="Sinh" typeface="Iskoola Pota"/>
+        <a:font script="Mong" typeface="Mongolian Baiti"/>
+        <a:font script="Viet" typeface="Times New Roman"/>
+        <a:font script="Uigh" typeface="Microsoft Uighur"/>
+        <a:font script="Geor" typeface="Sylfaen"/>
+      </a:majorFont>
+      <a:minorFont>
+        <a:latin typeface="Calibri"/>
+        <a:ea typeface=""/>
+        <a:cs typeface=""/>
+        <a:font script="Jpan" typeface="ＭＳ Ｐゴシック"/>
+        <a:font script="Hang" typeface="맑은 고딕"/>
+        <a:font script="Hans" typeface="宋体"/>
+        <a:font script="Hant" typeface="新細明體"/>
+        <a:font script="Arab" typeface="Arial"/>
+        <a:font script="Hebr" typeface="Arial"/>
+        <a:font script="Thai" typeface="Cordia New"/>
+        <a:font script="Ethi" typeface="Nyala"/>
+        <a:font script="Beng" typeface="Vrinda"/>
+        <a:font script="Gujr" typeface="Shruti"/>
+        <a:font script="Khmr" typeface="DaunPenh"/>
+        <a:font script="Knda" typeface="Tunga"/>
+        <a:font script="Guru" typeface="Raavi"/>
+        <a:font script="Cans" typeface="Euphemia"/>
+        <a:font script="Cher" typeface="Plantagenet Cherokee"/>
+        <a:font script="Yiii" typeface="Microsoft Yi Baiti"/>
+        <a:font script="Tibt" typeface="Microsoft Himalaya"/>
+        <a:font script="Thaa" typeface="MV Boli"/>
+        <a:font script="Deva" typeface="Mangal"/>
+        <a:font script="Telu" typeface="Gautami"/>
+        <a:font script="Taml" typeface="Latha"/>
+        <a:font script="Syrc" typeface="Estrangelo Edessa"/>
+        <a:font script="Orya" typeface="Kalinga"/>
+        <a:font script="Mlym" typeface="Kartika"/>
+        <a:font script="Laoo" typeface="DokChampa"/>
+        <a:font script="Sinh" typeface="Iskoola Pota"/>
+        <a:font script="Mong" typeface="Mongolian Baiti"/>
+        <a:font script="Viet" typeface="Arial"/>
+        <a:font script="Uigh" typeface="Microsoft Uighur"/>
+        <a:font script="Geor" typeface="Sylfaen"/>
+      </a:minorFont>
+    </a:fontScheme>
+    <a:fmtScheme name="Office">
+      <a:fillStyleLst>
+        <a:solidFill>
+          <a:schemeClr val="phClr"/>
+        </a:solidFill>
+        <a:gradFill rotWithShape="1">
+          <a:gsLst>
+            <a:gs pos="0">
+              <a:schemeClr val="phClr">
+                <a:tint val="50000"/>
+                <a:satMod val="300000"/>
+              </a:schemeClr>
+            </a:gs>
+            <a:gs pos="35000">
+              <a:schemeClr val="phClr">
+                <a:tint val="37000"/>
+                <a:satMod val="300000"/>
+              </a:schemeClr>
+            </a:gs>
+            <a:gs pos="100000">
+              <a:schemeClr val="phClr">
+                <a:tint val="15000"/>
+                <a:satMod val="350000"/>
+              </a:schemeClr>
+            </a:gs>
+          </a:gsLst>
+          <a:lin ang="16200000" scaled="1"/>
+        </a:gradFill>
+        <a:gradFill rotWithShape="1">
+          <a:gsLst>
+            <a:gs pos="0">
+              <a:schemeClr val="phClr">
+                <a:tint val="100000"/>
+                <a:shade val="100000"/>
+                <a:satMod val="130000"/>
+              </a:schemeClr>
+            </a:gs>
+            <a:gs pos="100000">
+              <a:schemeClr val="phClr">
+                <a:tint val="50000"/>
+                <a:shade val="100000"/>
+                <a:satMod val="350000"/>
+              </a:schemeClr>
+            </a:gs>
+          </a:gsLst>
+          <a:lin ang="16200000" scaled="0"/>
+        </a:gradFill>
+      </a:fillStyleLst>
+      <a:lnStyleLst>
+        <a:ln w="9525" cap="flat" cmpd="sng" algn="ctr">
+          <a:solidFill>
+            <a:schemeClr val="phClr">
+              <a:shade val="95000"/>
+              <a:satMod val="105000"/>
+            </a:schemeClr>
+          </a:solidFill>
+          <a:prstDash val="solid"/>
+        </a:ln>
+        <a:ln w="25400" cap="flat" cmpd="sng" algn="ctr">
+          <a:solidFill>
+            <a:schemeClr val="phClr"/>
+          </a:solidFill>
+          <a:prstDash val="solid"/>
+        </a:ln>
+        <a:ln w="38100" cap="flat" cmpd="sng" algn="ctr">
+          <a:solidFill>
+            <a:schemeClr val="phClr"/>
+          </a:solidFill>
+          <a:prstDash val="solid"/>
+        </a:ln>
+      </a:lnStyleLst>
+      <a:effectStyleLst>
+        <a:effectStyle>
+          <a:effectLst>
+            <a:outerShdw blurRad="40000" dist="20000" dir="5400000" rotWithShape="0">
+              <a:srgbClr val="000000">
+                <a:alpha val="38000"/>
+              </a:srgbClr>
+            </a:outerShdw>
+          </a:effectLst>
+        </a:effectStyle>
+        <a:effectStyle>
+          <a:effectLst>
+            <a:outerShdw blurRad="40000" dist="23000" dir="5400000" rotWithShape="0">
+              <a:srgbClr val="000000">
+                <a:alpha val="35000"/>
+              </a:srgbClr>
+            </a:outerShdw>
+          </a:effectLst>
+        </a:effectStyle>
+        <a:effectStyle>
+          <a:effectLst>
+            <a:outerShdw blurRad="40000" dist="23000" dir="5400000" rotWithShape="0">
+              <a:srgbClr val="000000">
+                <a:alpha val="35000"/>
+              </a:srgbClr>
+            </a:outerShdw>
+          </a:effectLst>
+          <a:scene3d>
+            <a:camera prst="orthographicFront">
+              <a:rot lat="0" lon="0" rev="0"/>
+            </a:camera>
+            <a:lightRig rig="threePt" dir="t">
+              <a:rot lat="0" lon="0" rev="1200000"/>
+            </a:lightRig>
+          </a:scene3d>
+          <a:sp3d>
+            <a:bevelT w="63500" h="25400"/>
+          </a:sp3d>
+        </a:effectStyle>
+      </a:effectStyleLst>
+      <a:bgFillStyleLst>
+        <a:solidFill>
+          <a:schemeClr val="phClr"/>
+        </a:solidFill>
+        <a:gradFill rotWithShape="1">
+          <a:gsLst>
+            <a:gs pos="0">
+              <a:schemeClr val="phClr">
+                <a:tint val="40000"/>
+                <a:satMod val="350000"/>
+              </a:schemeClr>
+            </a:gs>
+            <a:gs pos="40000">
+              <a:schemeClr val="phClr">
+                <a:tint val="45000"/>
+                <a:shade val="99000"/>
+                <a:satMod val="350000"/>
+              </a:schemeClr>
+            </a:gs>
+            <a:gs pos="100000">
+              <a:schemeClr val="phClr">
+                <a:shade val="20000"/>
+                <a:satMod val="255000"/>
+              </a:schemeClr>
+            </a:gs>
+          </a:gsLst>
+          <a:path path="circle">
+            <a:fillToRect l="50000" t="-80000" r="50000" b="180000"/>
+          </a:path>
+        </a:gradFill>
+        <a:gradFill rotWithShape="1">
+          <a:gsLst>
+            <a:gs pos="0">
+              <a:schemeClr val="phClr">
+                <a:tint val="80000"/>
+                <a:satMod val="300000"/>
+              </a:schemeClr>
+            </a:gs>
+            <a:gs pos="100000">
+              <a:schemeClr val="phClr">
+                <a:shade val="30000"/>
+                <a:satMod val="200000"/>
+              </a:schemeClr>
+            </a:gs>
+          </a:gsLst>
+          <a:path path="circle">
+            <a:fillToRect l="50000" t="50000" r="50000" b="50000"/>
+          </a:path>
+        </a:gradFill>
+      </a:bgFillStyleLst>
+    </a:fmtScheme>
+  </a:themeElements>
+  <a:objectDefaults>
+    <a:spDef>
+      <a:spPr/>
+      <a:bodyPr/>
+      <a:lstStyle/>
+      <a:style>
+        <a:lnRef idx="1">
+          <a:schemeClr val="accent1"/>
+        </a:lnRef>
+        <a:fillRef idx="3">
+          <a:schemeClr val="accent1"/>
+        </a:fillRef>
+        <a:effectRef idx="2">
+          <a:schemeClr val="accent1"/>
+        </a:effectRef>
+        <a:fontRef idx="minor">
+          <a:schemeClr val="lt1"/>
+        </a:fontRef>
+      </a:style>
+    </a:spDef>
+    <a:lnDef>
+      <a:spPr/>
+      <a:bodyPr/>
+      <a:lstStyle/>
+      <a:style>
+        <a:lnRef idx="2">
+          <a:schemeClr val="accent1"/>
+        </a:lnRef>
+        <a:fillRef idx="0">
+          <a:schemeClr val="accent1"/>
+        </a:fillRef>
+        <a:effectRef idx="1">
+          <a:schemeClr val="accent1"/>
+        </a:effectRef>
+        <a:fontRef idx="minor">
+          <a:schemeClr val="tx1"/>
+        </a:fontRef>
+      </a:style>
+    </a:lnDef>
+  </a:objectDefaults>
+  <a:extraClrSchemeLst/>
+</a:theme>
 </file>
</xml_diff>